<commit_message>
Rebuild the deck to the four-beat structure with a timed script
Five slides on the requested shape: hook, definition plus the divergence study
plus the company graph, a fast bridge into the demo, the demo card, and the
bonus.

Every slide carries speaker notes with the words to say, a word count and a
second count. The whole script is 406 spoken words, 162 seconds at 150 words a
minute, against a 180 second slot. The first draft ran 4:21, which would have
been cut off on stage.

The hook is now concrete rather than abstract: Marathon Petroleum is 15th of 18
on how clean it is today and 6th of 18 on how fast it is improving. Same data,
same year, nine places apart. That single fact carries the whole argument and it
comes out of our own grid.

The demo notes are a click-by-click script with timings, plus an explicit
failure path: if the tool breaks, skip to the last slide and never debug on
stage.

Co-Authored-By: Claude Opus 5 <noreply@anthropic.com>
</commit_message>
<xml_diff>
--- a/CONTESTED_pitch.pptx
+++ b/CONTESTED_pitch.pptx
@@ -6,11 +6,10 @@
   </p:sldMasterIdLst>
   <p:sldIdLst>
     <p:sldId id="256" r:id="rId7"/>
-    <p:sldId id="257" r:id="rId8"/>
-    <p:sldId id="258" r:id="rId9"/>
-    <p:sldId id="259" r:id="rId10"/>
-    <p:sldId id="260" r:id="rId11"/>
-    <p:sldId id="261" r:id="rId12"/>
+    <p:sldId id="257" r:id="rId9"/>
+    <p:sldId id="258" r:id="rId10"/>
+    <p:sldId id="259" r:id="rId11"/>
+    <p:sldId id="260" r:id="rId12"/>
   </p:sldIdLst>
   <p:sldSz cx="12191695" cy="6858000" type="screen4x3"/>
   <p:notesSz cx="6858000" cy="9144000"/>
@@ -110,6 +109,989 @@
     </a:lvl9pPr>
   </p:defaultTextStyle>
 </p:presentation>
+</file>
+
+<file path=ppt/notesMasters/notesMaster1.xml><?xml version="1.0" encoding="utf-8"?>
+<p:notesMaster xmlns:a="http://schemas.openxmlformats.org/drawingml/2006/main" xmlns:p="http://schemas.openxmlformats.org/presentationml/2006/main" xmlns:r="http://schemas.openxmlformats.org/officeDocument/2006/relationships">
+  <p:cSld>
+    <p:bg>
+      <p:bgRef idx="1001">
+        <a:schemeClr val="bg1"/>
+      </p:bgRef>
+    </p:bg>
+    <p:spTree>
+      <p:nvGrpSpPr>
+        <p:cNvPr id="1" name=""/>
+        <p:cNvGrpSpPr/>
+        <p:nvPr/>
+      </p:nvGrpSpPr>
+      <p:grpSpPr>
+        <a:xfrm>
+          <a:off x="0" y="0"/>
+          <a:ext cx="0" cy="0"/>
+          <a:chOff x="0" y="0"/>
+          <a:chExt cx="0" cy="0"/>
+        </a:xfrm>
+      </p:grpSpPr>
+      <p:sp>
+        <p:nvSpPr>
+          <p:cNvPr id="2" name="Header Placeholder 1"/>
+          <p:cNvSpPr>
+            <a:spLocks noGrp="1"/>
+          </p:cNvSpPr>
+          <p:nvPr>
+            <p:ph type="hdr" sz="quarter"/>
+          </p:nvPr>
+        </p:nvSpPr>
+        <p:spPr>
+          <a:xfrm>
+            <a:off x="0" y="0"/>
+            <a:ext cx="2971800" cy="457200"/>
+          </a:xfrm>
+          <a:prstGeom prst="rect">
+            <a:avLst/>
+          </a:prstGeom>
+        </p:spPr>
+        <p:txBody>
+          <a:bodyPr vert="horz" lIns="91440" tIns="45720" rIns="91440" bIns="45720" rtlCol="0"/>
+          <a:lstStyle>
+            <a:lvl1pPr algn="l">
+              <a:defRPr sz="1200"/>
+            </a:lvl1pPr>
+          </a:lstStyle>
+          <a:p>
+            <a:endParaRPr lang="en-US"/>
+          </a:p>
+        </p:txBody>
+      </p:sp>
+      <p:sp>
+        <p:nvSpPr>
+          <p:cNvPr id="3" name="Date Placeholder 2"/>
+          <p:cNvSpPr>
+            <a:spLocks noGrp="1"/>
+          </p:cNvSpPr>
+          <p:nvPr>
+            <p:ph type="dt" idx="1"/>
+          </p:nvPr>
+        </p:nvSpPr>
+        <p:spPr>
+          <a:xfrm>
+            <a:off x="3884613" y="0"/>
+            <a:ext cx="2971800" cy="457200"/>
+          </a:xfrm>
+          <a:prstGeom prst="rect">
+            <a:avLst/>
+          </a:prstGeom>
+        </p:spPr>
+        <p:txBody>
+          <a:bodyPr vert="horz" lIns="91440" tIns="45720" rIns="91440" bIns="45720" rtlCol="0"/>
+          <a:lstStyle>
+            <a:lvl1pPr algn="r">
+              <a:defRPr sz="1200"/>
+            </a:lvl1pPr>
+          </a:lstStyle>
+          <a:p>
+            <a:fld id="{0F89C1C7-3DCD-1040-A9CF-14679D8B5DDD}" type="datetimeFigureOut">
+              <a:rPr lang="en-US" smtClean="0"/>
+              <a:t>10/17/16</a:t>
+            </a:fld>
+            <a:endParaRPr lang="en-US"/>
+          </a:p>
+        </p:txBody>
+      </p:sp>
+      <p:sp>
+        <p:nvSpPr>
+          <p:cNvPr id="4" name="Slide Image Placeholder 3"/>
+          <p:cNvSpPr>
+            <a:spLocks noGrp="1" noRot="1" noChangeAspect="1"/>
+          </p:cNvSpPr>
+          <p:nvPr>
+            <p:ph type="sldImg" idx="2"/>
+          </p:nvPr>
+        </p:nvSpPr>
+        <p:spPr>
+          <a:xfrm>
+            <a:off x="1143000" y="685800"/>
+            <a:ext cx="4572000" cy="3429000"/>
+          </a:xfrm>
+          <a:prstGeom prst="rect">
+            <a:avLst/>
+          </a:prstGeom>
+          <a:noFill/>
+          <a:ln w="12700">
+            <a:solidFill>
+              <a:prstClr val="black"/>
+            </a:solidFill>
+          </a:ln>
+        </p:spPr>
+        <p:txBody>
+          <a:bodyPr vert="horz" lIns="91440" tIns="45720" rIns="91440" bIns="45720" rtlCol="0" anchor="ctr"/>
+          <a:lstStyle/>
+          <a:p>
+            <a:endParaRPr lang="en-US"/>
+          </a:p>
+        </p:txBody>
+      </p:sp>
+      <p:sp>
+        <p:nvSpPr>
+          <p:cNvPr id="5" name="Notes Placeholder 4"/>
+          <p:cNvSpPr>
+            <a:spLocks noGrp="1"/>
+          </p:cNvSpPr>
+          <p:nvPr>
+            <p:ph type="body" sz="quarter" idx="3"/>
+          </p:nvPr>
+        </p:nvSpPr>
+        <p:spPr>
+          <a:xfrm>
+            <a:off x="685800" y="4343400"/>
+            <a:ext cx="5486400" cy="4114800"/>
+          </a:xfrm>
+          <a:prstGeom prst="rect">
+            <a:avLst/>
+          </a:prstGeom>
+        </p:spPr>
+        <p:txBody>
+          <a:bodyPr vert="horz" lIns="91440" tIns="45720" rIns="91440" bIns="45720" rtlCol="0"/>
+          <a:lstStyle/>
+          <a:p>
+            <a:pPr lvl="0"/>
+            <a:r>
+              <a:rPr lang="en-US" smtClean="0"/>
+              <a:t>Click to edit Master text styles</a:t>
+            </a:r>
+          </a:p>
+          <a:p>
+            <a:pPr lvl="1"/>
+            <a:r>
+              <a:rPr lang="en-US" smtClean="0"/>
+              <a:t>Second level</a:t>
+            </a:r>
+          </a:p>
+          <a:p>
+            <a:pPr lvl="2"/>
+            <a:r>
+              <a:rPr lang="en-US" smtClean="0"/>
+              <a:t>Third level</a:t>
+            </a:r>
+          </a:p>
+          <a:p>
+            <a:pPr lvl="3"/>
+            <a:r>
+              <a:rPr lang="en-US" smtClean="0"/>
+              <a:t>Fourth level</a:t>
+            </a:r>
+          </a:p>
+          <a:p>
+            <a:pPr lvl="4"/>
+            <a:r>
+              <a:rPr lang="en-US" smtClean="0"/>
+              <a:t>Fifth level</a:t>
+            </a:r>
+            <a:endParaRPr lang="en-US"/>
+          </a:p>
+        </p:txBody>
+      </p:sp>
+      <p:sp>
+        <p:nvSpPr>
+          <p:cNvPr id="6" name="Footer Placeholder 5"/>
+          <p:cNvSpPr>
+            <a:spLocks noGrp="1"/>
+          </p:cNvSpPr>
+          <p:nvPr>
+            <p:ph type="ftr" sz="quarter" idx="4"/>
+          </p:nvPr>
+        </p:nvSpPr>
+        <p:spPr>
+          <a:xfrm>
+            <a:off x="0" y="8685213"/>
+            <a:ext cx="2971800" cy="457200"/>
+          </a:xfrm>
+          <a:prstGeom prst="rect">
+            <a:avLst/>
+          </a:prstGeom>
+        </p:spPr>
+        <p:txBody>
+          <a:bodyPr vert="horz" lIns="91440" tIns="45720" rIns="91440" bIns="45720" rtlCol="0" anchor="b"/>
+          <a:lstStyle>
+            <a:lvl1pPr algn="l">
+              <a:defRPr sz="1200"/>
+            </a:lvl1pPr>
+          </a:lstStyle>
+          <a:p>
+            <a:endParaRPr lang="en-US"/>
+          </a:p>
+        </p:txBody>
+      </p:sp>
+      <p:sp>
+        <p:nvSpPr>
+          <p:cNvPr id="7" name="Slide Number Placeholder 6"/>
+          <p:cNvSpPr>
+            <a:spLocks noGrp="1"/>
+          </p:cNvSpPr>
+          <p:nvPr>
+            <p:ph type="sldNum" sz="quarter" idx="5"/>
+          </p:nvPr>
+        </p:nvSpPr>
+        <p:spPr>
+          <a:xfrm>
+            <a:off x="3884613" y="8685213"/>
+            <a:ext cx="2971800" cy="457200"/>
+          </a:xfrm>
+          <a:prstGeom prst="rect">
+            <a:avLst/>
+          </a:prstGeom>
+        </p:spPr>
+        <p:txBody>
+          <a:bodyPr vert="horz" lIns="91440" tIns="45720" rIns="91440" bIns="45720" rtlCol="0" anchor="b"/>
+          <a:lstStyle>
+            <a:lvl1pPr algn="r">
+              <a:defRPr sz="1200"/>
+            </a:lvl1pPr>
+          </a:lstStyle>
+          <a:p>
+            <a:fld id="{BB5E49A5-4136-284D-997B-48E1D791AD67}" type="slidenum">
+              <a:rPr lang="en-US" smtClean="0"/>
+              <a:t>‹#›</a:t>
+            </a:fld>
+            <a:endParaRPr lang="en-US"/>
+          </a:p>
+        </p:txBody>
+      </p:sp>
+    </p:spTree>
+    <p:extLst>
+      <p:ext uri="{BB962C8B-B14F-4D97-AF65-F5344CB8AC3E}">
+        <p14:creationId xmlns:p14="http://schemas.microsoft.com/office/powerpoint/2010/main" val="2623252185"/>
+      </p:ext>
+    </p:extLst>
+  </p:cSld>
+  <p:clrMap bg1="lt1" tx1="dk1" bg2="lt2" tx2="dk2" accent1="accent1" accent2="accent2" accent3="accent3" accent4="accent4" accent5="accent5" accent6="accent6" hlink="hlink" folHlink="folHlink"/>
+  <p:notesStyle>
+    <a:lvl1pPr marL="0" algn="l" defTabSz="457200" rtl="0" eaLnBrk="1" latinLnBrk="0" hangingPunct="1">
+      <a:defRPr sz="1200" kern="1200">
+        <a:solidFill>
+          <a:schemeClr val="tx1"/>
+        </a:solidFill>
+        <a:latin typeface="+mn-lt"/>
+        <a:ea typeface="+mn-ea"/>
+        <a:cs typeface="+mn-cs"/>
+      </a:defRPr>
+    </a:lvl1pPr>
+    <a:lvl2pPr marL="457200" algn="l" defTabSz="457200" rtl="0" eaLnBrk="1" latinLnBrk="0" hangingPunct="1">
+      <a:defRPr sz="1200" kern="1200">
+        <a:solidFill>
+          <a:schemeClr val="tx1"/>
+        </a:solidFill>
+        <a:latin typeface="+mn-lt"/>
+        <a:ea typeface="+mn-ea"/>
+        <a:cs typeface="+mn-cs"/>
+      </a:defRPr>
+    </a:lvl2pPr>
+    <a:lvl3pPr marL="914400" algn="l" defTabSz="457200" rtl="0" eaLnBrk="1" latinLnBrk="0" hangingPunct="1">
+      <a:defRPr sz="1200" kern="1200">
+        <a:solidFill>
+          <a:schemeClr val="tx1"/>
+        </a:solidFill>
+        <a:latin typeface="+mn-lt"/>
+        <a:ea typeface="+mn-ea"/>
+        <a:cs typeface="+mn-cs"/>
+      </a:defRPr>
+    </a:lvl3pPr>
+    <a:lvl4pPr marL="1371600" algn="l" defTabSz="457200" rtl="0" eaLnBrk="1" latinLnBrk="0" hangingPunct="1">
+      <a:defRPr sz="1200" kern="1200">
+        <a:solidFill>
+          <a:schemeClr val="tx1"/>
+        </a:solidFill>
+        <a:latin typeface="+mn-lt"/>
+        <a:ea typeface="+mn-ea"/>
+        <a:cs typeface="+mn-cs"/>
+      </a:defRPr>
+    </a:lvl4pPr>
+    <a:lvl5pPr marL="1828800" algn="l" defTabSz="457200" rtl="0" eaLnBrk="1" latinLnBrk="0" hangingPunct="1">
+      <a:defRPr sz="1200" kern="1200">
+        <a:solidFill>
+          <a:schemeClr val="tx1"/>
+        </a:solidFill>
+        <a:latin typeface="+mn-lt"/>
+        <a:ea typeface="+mn-ea"/>
+        <a:cs typeface="+mn-cs"/>
+      </a:defRPr>
+    </a:lvl5pPr>
+    <a:lvl6pPr marL="2286000" algn="l" defTabSz="457200" rtl="0" eaLnBrk="1" latinLnBrk="0" hangingPunct="1">
+      <a:defRPr sz="1200" kern="1200">
+        <a:solidFill>
+          <a:schemeClr val="tx1"/>
+        </a:solidFill>
+        <a:latin typeface="+mn-lt"/>
+        <a:ea typeface="+mn-ea"/>
+        <a:cs typeface="+mn-cs"/>
+      </a:defRPr>
+    </a:lvl6pPr>
+    <a:lvl7pPr marL="2743200" algn="l" defTabSz="457200" rtl="0" eaLnBrk="1" latinLnBrk="0" hangingPunct="1">
+      <a:defRPr sz="1200" kern="1200">
+        <a:solidFill>
+          <a:schemeClr val="tx1"/>
+        </a:solidFill>
+        <a:latin typeface="+mn-lt"/>
+        <a:ea typeface="+mn-ea"/>
+        <a:cs typeface="+mn-cs"/>
+      </a:defRPr>
+    </a:lvl7pPr>
+    <a:lvl8pPr marL="3200400" algn="l" defTabSz="457200" rtl="0" eaLnBrk="1" latinLnBrk="0" hangingPunct="1">
+      <a:defRPr sz="1200" kern="1200">
+        <a:solidFill>
+          <a:schemeClr val="tx1"/>
+        </a:solidFill>
+        <a:latin typeface="+mn-lt"/>
+        <a:ea typeface="+mn-ea"/>
+        <a:cs typeface="+mn-cs"/>
+      </a:defRPr>
+    </a:lvl8pPr>
+    <a:lvl9pPr marL="3657600" algn="l" defTabSz="457200" rtl="0" eaLnBrk="1" latinLnBrk="0" hangingPunct="1">
+      <a:defRPr sz="1200" kern="1200">
+        <a:solidFill>
+          <a:schemeClr val="tx1"/>
+        </a:solidFill>
+        <a:latin typeface="+mn-lt"/>
+        <a:ea typeface="+mn-ea"/>
+        <a:cs typeface="+mn-cs"/>
+      </a:defRPr>
+    </a:lvl9pPr>
+  </p:notesStyle>
+</p:notesMaster>
+</file>
+
+<file path=ppt/notesSlides/notesSlide1.xml><?xml version="1.0" encoding="utf-8"?>
+<p:notes xmlns:a="http://schemas.openxmlformats.org/drawingml/2006/main" xmlns:p="http://schemas.openxmlformats.org/presentationml/2006/main" xmlns:r="http://schemas.openxmlformats.org/officeDocument/2006/relationships">
+  <p:cSld>
+    <p:spTree>
+      <p:nvGrpSpPr>
+        <p:cNvPr id="1" name=""/>
+        <p:cNvGrpSpPr/>
+        <p:nvPr/>
+      </p:nvGrpSpPr>
+      <p:grpSpPr>
+        <a:xfrm>
+          <a:off x="0" y="0"/>
+          <a:ext cx="0" cy="0"/>
+          <a:chOff x="0" y="0"/>
+          <a:chExt cx="0" cy="0"/>
+        </a:xfrm>
+      </p:grpSpPr>
+      <p:sp>
+        <p:nvSpPr>
+          <p:cNvPr id="2" name="Slide Image Placeholder 1"/>
+          <p:cNvSpPr>
+            <a:spLocks noGrp="1"/>
+          </p:cNvSpPr>
+          <p:nvPr>
+            <p:ph type="sldImg" idx="2"/>
+          </p:nvPr>
+        </p:nvSpPr>
+        <p:spPr/>
+      </p:sp>
+      <p:sp>
+        <p:nvSpPr>
+          <p:cNvPr id="3" name="Notes Placeholder 2"/>
+          <p:cNvSpPr>
+            <a:spLocks noGrp="1"/>
+          </p:cNvSpPr>
+          <p:nvPr>
+            <p:ph type="body" idx="3" sz="quarter"/>
+          </p:nvPr>
+        </p:nvSpPr>
+        <p:spPr/>
+        <p:txBody>
+          <a:bodyPr/>
+          <a:lstStyle/>
+          <a:p>
+            <a:r>
+              <a:t>HOOK  |  32 sec  |  78 spoken words  |  slow, this is the whole pitch</a:t>
+            </a:r>
+          </a:p>
+          <a:p/>
+          <a:p>
+            <a:r>
+              <a:t>SAY:</a:t>
+            </a:r>
+          </a:p>
+          <a:p>
+            <a:r>
+              <a:t>"Marathon Petroleum. Fifteenth of eighteen energy companies on how clean it is</a:t>
+            </a:r>
+          </a:p>
+          <a:p>
+            <a:r>
+              <a:t>today. Sixth of eighteen on how fast it is improving.</a:t>
+            </a:r>
+          </a:p>
+          <a:p/>
+          <a:p>
+            <a:r>
+              <a:t>Same company. Same data. Same year.</a:t>
+            </a:r>
+          </a:p>
+          <a:p/>
+          <a:p>
+            <a:r>
+              <a:t>[PAUSE ONE BEAT]</a:t>
+            </a:r>
+          </a:p>
+          <a:p/>
+          <a:p>
+            <a:r>
+              <a:t>Neither number is wrong. They answer two different questions, and the rating</a:t>
+            </a:r>
+          </a:p>
+          <a:p>
+            <a:r>
+              <a:t>industry publishes one of them without telling you which.</a:t>
+            </a:r>
+          </a:p>
+          <a:p/>
+          <a:p>
+            <a:r>
+              <a:t>That is what an ESG score is. One answer to a question nobody wrote down.</a:t>
+            </a:r>
+          </a:p>
+          <a:p>
+            <a:r>
+              <a:t>We publish the question, the answer, and how much the answer depends on the</a:t>
+            </a:r>
+          </a:p>
+          <a:p>
+            <a:r>
+              <a:t>question."</a:t>
+            </a:r>
+          </a:p>
+          <a:p/>
+          <a:p>
+            <a:r>
+              <a:t>DO NOT say methodology, specification or grid on this slide.</a:t>
+            </a:r>
+          </a:p>
+        </p:txBody>
+      </p:sp>
+      <p:sp>
+        <p:nvSpPr>
+          <p:cNvPr id="4" name="Slide Number Placeholder 3"/>
+          <p:cNvSpPr>
+            <a:spLocks noGrp="1"/>
+          </p:cNvSpPr>
+          <p:nvPr>
+            <p:ph type="sldNum" idx="5" sz="quarter"/>
+          </p:nvPr>
+        </p:nvSpPr>
+        <p:spPr/>
+      </p:sp>
+    </p:spTree>
+  </p:cSld>
+  <p:clrMapOvr>
+    <a:masterClrMapping/>
+  </p:clrMapOvr>
+</p:notes>
+</file>
+
+<file path=ppt/notesSlides/notesSlide2.xml><?xml version="1.0" encoding="utf-8"?>
+<p:notes xmlns:a="http://schemas.openxmlformats.org/drawingml/2006/main" xmlns:p="http://schemas.openxmlformats.org/presentationml/2006/main" xmlns:r="http://schemas.openxmlformats.org/officeDocument/2006/relationships">
+  <p:cSld>
+    <p:spTree>
+      <p:nvGrpSpPr>
+        <p:cNvPr id="1" name=""/>
+        <p:cNvGrpSpPr/>
+        <p:nvPr/>
+      </p:nvGrpSpPr>
+      <p:grpSpPr>
+        <a:xfrm>
+          <a:off x="0" y="0"/>
+          <a:ext cx="0" cy="0"/>
+          <a:chOff x="0" y="0"/>
+          <a:chExt cx="0" cy="0"/>
+        </a:xfrm>
+      </p:grpSpPr>
+      <p:sp>
+        <p:nvSpPr>
+          <p:cNvPr id="2" name="Slide Image Placeholder 1"/>
+          <p:cNvSpPr>
+            <a:spLocks noGrp="1"/>
+          </p:cNvSpPr>
+          <p:nvPr>
+            <p:ph type="sldImg" idx="2"/>
+          </p:nvPr>
+        </p:nvSpPr>
+        <p:spPr/>
+      </p:sp>
+      <p:sp>
+        <p:nvSpPr>
+          <p:cNvPr id="3" name="Notes Placeholder 2"/>
+          <p:cNvSpPr>
+            <a:spLocks noGrp="1"/>
+          </p:cNvSpPr>
+          <p:nvPr>
+            <p:ph type="body" idx="3" sz="quarter"/>
+          </p:nvPr>
+        </p:nvSpPr>
+        <p:spPr/>
+        <p:txBody>
+          <a:bodyPr/>
+          <a:lstStyle/>
+          <a:p>
+            <a:r>
+              <a:t>DEFINITION + STUDY + COMPANIES  |  40 sec  |  103 spoken words</a:t>
+            </a:r>
+          </a:p>
+          <a:p/>
+          <a:p>
+            <a:r>
+              <a:t>SAY:</a:t>
+            </a:r>
+          </a:p>
+          <a:p>
+            <a:r>
+              <a:t>"Our definition: less irreversible harm per unit of output than the peers making</a:t>
+            </a:r>
+          </a:p>
+          <a:p>
+            <a:r>
+              <a:t>the same product, and a balance sheet that survives the transition. Financial</a:t>
+            </a:r>
+          </a:p>
+          <a:p>
+            <a:r>
+              <a:t>resilience is in there because a company in distress cuts abatement first.</a:t>
+            </a:r>
+          </a:p>
+          <a:p/>
+          <a:p>
+            <a:r>
+              <a:t>Why do raters disagree? Berg and co-authors decomposed it. Fifty-six percent is</a:t>
+            </a:r>
+          </a:p>
+          <a:p>
+            <a:r>
+              <a:t>measurement. Thirty-eight percent is scope. Only six percent is the pillar</a:t>
+            </a:r>
+          </a:p>
+          <a:p>
+            <a:r>
+              <a:t>weighting, which is the only part anyone lets you touch.</a:t>
+            </a:r>
+          </a:p>
+          <a:p/>
+          <a:p>
+            <a:r>
+              <a:t>So we attack the ninety-four percent. Nine choices where MSCI and Bloomberg</a:t>
+            </a:r>
+          </a:p>
+          <a:p>
+            <a:r>
+              <a:t>publish different methods, every combination.</a:t>
+            </a:r>
+          </a:p>
+          <a:p/>
+          <a:p>
+            <a:r>
+              <a:t>Right: all eighteen companies, both questions. Bar length is how far the answer</a:t>
+            </a:r>
+          </a:p>
+          <a:p>
+            <a:r>
+              <a:t>moves on method alone."</a:t>
+            </a:r>
+          </a:p>
+          <a:p/>
+          <a:p>
+            <a:r>
+              <a:t>LAND 56 / 38 / 6 CLEARLY. Paraphrase the definition, do not read it.</a:t>
+            </a:r>
+          </a:p>
+        </p:txBody>
+      </p:sp>
+      <p:sp>
+        <p:nvSpPr>
+          <p:cNvPr id="4" name="Slide Number Placeholder 3"/>
+          <p:cNvSpPr>
+            <a:spLocks noGrp="1"/>
+          </p:cNvSpPr>
+          <p:nvPr>
+            <p:ph type="sldNum" idx="5" sz="quarter"/>
+          </p:nvPr>
+        </p:nvSpPr>
+        <p:spPr/>
+      </p:sp>
+    </p:spTree>
+  </p:cSld>
+  <p:clrMapOvr>
+    <a:masterClrMapping/>
+  </p:clrMapOvr>
+</p:notes>
+</file>
+
+<file path=ppt/notesSlides/notesSlide3.xml><?xml version="1.0" encoding="utf-8"?>
+<p:notes xmlns:a="http://schemas.openxmlformats.org/drawingml/2006/main" xmlns:p="http://schemas.openxmlformats.org/presentationml/2006/main" xmlns:r="http://schemas.openxmlformats.org/officeDocument/2006/relationships">
+  <p:cSld>
+    <p:spTree>
+      <p:nvGrpSpPr>
+        <p:cNvPr id="1" name=""/>
+        <p:cNvGrpSpPr/>
+        <p:nvPr/>
+      </p:nvGrpSpPr>
+      <p:grpSpPr>
+        <a:xfrm>
+          <a:off x="0" y="0"/>
+          <a:ext cx="0" cy="0"/>
+          <a:chOff x="0" y="0"/>
+          <a:chExt cx="0" cy="0"/>
+        </a:xfrm>
+      </p:grpSpPr>
+      <p:sp>
+        <p:nvSpPr>
+          <p:cNvPr id="2" name="Slide Image Placeholder 1"/>
+          <p:cNvSpPr>
+            <a:spLocks noGrp="1"/>
+          </p:cNvSpPr>
+          <p:nvPr>
+            <p:ph type="sldImg" idx="2"/>
+          </p:nvPr>
+        </p:nvSpPr>
+        <p:spPr/>
+      </p:sp>
+      <p:sp>
+        <p:nvSpPr>
+          <p:cNvPr id="3" name="Notes Placeholder 2"/>
+          <p:cNvSpPr>
+            <a:spLocks noGrp="1"/>
+          </p:cNvSpPr>
+          <p:nvPr>
+            <p:ph type="body" idx="3" sz="quarter"/>
+          </p:nvPr>
+        </p:nvSpPr>
+        <p:spPr/>
+        <p:txBody>
+          <a:bodyPr/>
+          <a:lstStyle/>
+          <a:p>
+            <a:r>
+              <a:t>BRIDGE  |  12 sec  |  32 spoken words  |  fast</a:t>
+            </a:r>
+          </a:p>
+          <a:p/>
+          <a:p>
+            <a:r>
+              <a:t>SAY:</a:t>
+            </a:r>
+          </a:p>
+          <a:p>
+            <a:r>
+              <a:t>"Why energy? Hardest sector to score. Only three of thirty-seven environmental</a:t>
+            </a:r>
+          </a:p>
+          <a:p>
+            <a:r>
+              <a:t>fields are reported by all eighteen companies. Scope Three is absent entirely,</a:t>
+            </a:r>
+          </a:p>
+          <a:p>
+            <a:r>
+              <a:t>and we say so. Let me show you."</a:t>
+            </a:r>
+          </a:p>
+          <a:p/>
+          <a:p>
+            <a:r>
+              <a:t>THEN SWITCH TO THE BROWSER IMMEDIATELY.</a:t>
+            </a:r>
+          </a:p>
+        </p:txBody>
+      </p:sp>
+      <p:sp>
+        <p:nvSpPr>
+          <p:cNvPr id="4" name="Slide Number Placeholder 3"/>
+          <p:cNvSpPr>
+            <a:spLocks noGrp="1"/>
+          </p:cNvSpPr>
+          <p:nvPr>
+            <p:ph type="sldNum" idx="5" sz="quarter"/>
+          </p:nvPr>
+        </p:nvSpPr>
+        <p:spPr/>
+      </p:sp>
+    </p:spTree>
+  </p:cSld>
+  <p:clrMapOvr>
+    <a:masterClrMapping/>
+  </p:clrMapOvr>
+</p:notes>
+</file>
+
+<file path=ppt/notesSlides/notesSlide4.xml><?xml version="1.0" encoding="utf-8"?>
+<p:notes xmlns:a="http://schemas.openxmlformats.org/drawingml/2006/main" xmlns:p="http://schemas.openxmlformats.org/presentationml/2006/main" xmlns:r="http://schemas.openxmlformats.org/officeDocument/2006/relationships">
+  <p:cSld>
+    <p:spTree>
+      <p:nvGrpSpPr>
+        <p:cNvPr id="1" name=""/>
+        <p:cNvGrpSpPr/>
+        <p:nvPr/>
+      </p:nvGrpSpPr>
+      <p:grpSpPr>
+        <a:xfrm>
+          <a:off x="0" y="0"/>
+          <a:ext cx="0" cy="0"/>
+          <a:chOff x="0" y="0"/>
+          <a:chExt cx="0" cy="0"/>
+        </a:xfrm>
+      </p:grpSpPr>
+      <p:sp>
+        <p:nvSpPr>
+          <p:cNvPr id="2" name="Slide Image Placeholder 1"/>
+          <p:cNvSpPr>
+            <a:spLocks noGrp="1"/>
+          </p:cNvSpPr>
+          <p:nvPr>
+            <p:ph type="sldImg" idx="2"/>
+          </p:nvPr>
+        </p:nvSpPr>
+        <p:spPr/>
+      </p:sp>
+      <p:sp>
+        <p:nvSpPr>
+          <p:cNvPr id="3" name="Notes Placeholder 2"/>
+          <p:cNvSpPr>
+            <a:spLocks noGrp="1"/>
+          </p:cNvSpPr>
+          <p:nvPr>
+            <p:ph type="body" idx="3" sz="quarter"/>
+          </p:nvPr>
+        </p:nvSpPr>
+        <p:spPr/>
+        <p:txBody>
+          <a:bodyPr/>
+          <a:lstStyle/>
+          <a:p>
+            <a:r>
+              <a:t>DEMO  |  68 sec  |  170 spoken words  |  DO EXACTLY THIS</a:t>
+            </a:r>
+          </a:p>
+          <a:p/>
+          <a:p>
+            <a:r>
+              <a:t>1 (8s) "Eighteen companies ranked. Consensus here. This bar is how much of that</a:t>
+            </a:r>
+          </a:p>
+          <a:p>
+            <a:r>
+              <a:t>   rank is a choice."</a:t>
+            </a:r>
+          </a:p>
+          <a:p/>
+          <a:p>
+            <a:r>
+              <a:t>2 (15s) DRAG THE ENVIRONMENT SLIDER.</a:t>
+            </a:r>
+          </a:p>
+          <a:p>
+            <a:r>
+              <a:t>   "This is what every provider gives you. Pillar weights. It moves the median</a:t>
+            </a:r>
+          </a:p>
+          <a:p>
+            <a:r>
+              <a:t>   company three places. That is the six percent."</a:t>
+            </a:r>
+          </a:p>
+          <a:p/>
+          <a:p>
+            <a:r>
+              <a:t>3 (20s) PIN Direction to LEVEL, then Evidence bar to STRICT.</a:t>
+            </a:r>
+          </a:p>
+          <a:p>
+            <a:r>
+              <a:t>   "Here is what nobody gives you. This is the question I am asking. And this is</a:t>
+            </a:r>
+          </a:p>
+          <a:p>
+            <a:r>
+              <a:t>   how demanding I am about evidence."</a:t>
+            </a:r>
+          </a:p>
+          <a:p/>
+          <a:p>
+            <a:r>
+              <a:t>4 (15s) POINT AT THE SETTLED COUNTER.</a:t>
+            </a:r>
+          </a:p>
+          <a:p>
+            <a:r>
+              <a:t>   "Thirty-three of a hundred and fifty-three comparisons survive every method.</a:t>
+            </a:r>
+          </a:p>
+          <a:p>
+            <a:r>
+              <a:t>   Raise the bar, fifty-six. A league table asserts all hundred and fifty-three."</a:t>
+            </a:r>
+          </a:p>
+          <a:p/>
+          <a:p>
+            <a:r>
+              <a:t>5 (10s) HOVER A POINT ON THE CURVE.</a:t>
+            </a:r>
+          </a:p>
+          <a:p>
+            <a:r>
+              <a:t>   "Every point tells you which nine choices produced it. No black box."</a:t>
+            </a:r>
+          </a:p>
+          <a:p/>
+          <a:p>
+            <a:r>
+              <a:t>IF IT BREAKS: skip to the last slide, say "numbers are in the paper, tool is in</a:t>
+            </a:r>
+          </a:p>
+          <a:p>
+            <a:r>
+              <a:t>the repo". Never debug on stage.</a:t>
+            </a:r>
+          </a:p>
+        </p:txBody>
+      </p:sp>
+      <p:sp>
+        <p:nvSpPr>
+          <p:cNvPr id="4" name="Slide Number Placeholder 3"/>
+          <p:cNvSpPr>
+            <a:spLocks noGrp="1"/>
+          </p:cNvSpPr>
+          <p:nvPr>
+            <p:ph type="sldNum" idx="5" sz="quarter"/>
+          </p:nvPr>
+        </p:nvSpPr>
+        <p:spPr/>
+      </p:sp>
+    </p:spTree>
+  </p:cSld>
+  <p:clrMapOvr>
+    <a:masterClrMapping/>
+  </p:clrMapOvr>
+</p:notes>
+</file>
+
+<file path=ppt/notesSlides/notesSlide5.xml><?xml version="1.0" encoding="utf-8"?>
+<p:notes xmlns:a="http://schemas.openxmlformats.org/drawingml/2006/main" xmlns:p="http://schemas.openxmlformats.org/presentationml/2006/main" xmlns:r="http://schemas.openxmlformats.org/officeDocument/2006/relationships">
+  <p:cSld>
+    <p:spTree>
+      <p:nvGrpSpPr>
+        <p:cNvPr id="1" name=""/>
+        <p:cNvGrpSpPr/>
+        <p:nvPr/>
+      </p:nvGrpSpPr>
+      <p:grpSpPr>
+        <a:xfrm>
+          <a:off x="0" y="0"/>
+          <a:ext cx="0" cy="0"/>
+          <a:chOff x="0" y="0"/>
+          <a:chExt cx="0" cy="0"/>
+        </a:xfrm>
+      </p:grpSpPr>
+      <p:sp>
+        <p:nvSpPr>
+          <p:cNvPr id="2" name="Slide Image Placeholder 1"/>
+          <p:cNvSpPr>
+            <a:spLocks noGrp="1"/>
+          </p:cNvSpPr>
+          <p:nvPr>
+            <p:ph type="sldImg" idx="2"/>
+          </p:nvPr>
+        </p:nvSpPr>
+        <p:spPr/>
+      </p:sp>
+      <p:sp>
+        <p:nvSpPr>
+          <p:cNvPr id="3" name="Notes Placeholder 2"/>
+          <p:cNvSpPr>
+            <a:spLocks noGrp="1"/>
+          </p:cNvSpPr>
+          <p:nvPr>
+            <p:ph type="body" idx="3" sz="quarter"/>
+          </p:nvPr>
+        </p:nvSpPr>
+        <p:spPr/>
+        <p:txBody>
+          <a:bodyPr/>
+          <a:lstStyle/>
+          <a:p>
+            <a:r>
+              <a:t>BONUS + CLOSE  |  28 sec  |  70 spoken words</a:t>
+            </a:r>
+          </a:p>
+          <a:p/>
+          <a:p>
+            <a:r>
+              <a:t>SAY:</a:t>
+            </a:r>
+          </a:p>
+          <a:p>
+            <a:r>
+              <a:t>"The bonus. The thesis is that crossing an ESG threshold unlocks a wall of</a:t>
+            </a:r>
+          </a:p>
+          <a:p>
+            <a:r>
+              <a:t>capital. We tested it. There is no threshold: fifteen of eighteen companies sit</a:t>
+            </a:r>
+          </a:p>
+          <a:p>
+            <a:r>
+              <a:t>between twenty and eighty percent likely to pass a screen.</a:t>
+            </a:r>
+          </a:p>
+          <a:p/>
+          <a:p>
+            <a:r>
+              <a:t>So the trade is the gap between where a company stands and where it is heading.</a:t>
+            </a:r>
+          </a:p>
+          <a:p>
+            <a:r>
+              <a:t>We go long the gap, short the structurally stuck, and sell when the gap closes.</a:t>
+            </a:r>
+          </a:p>
+          <a:p/>
+          <a:p>
+            <a:r>
+              <a:t>We give you the ranking the brief asked for, and the honest error bar around it.</a:t>
+            </a:r>
+          </a:p>
+          <a:p>
+            <a:r>
+              <a:t>Thank you."</a:t>
+            </a:r>
+          </a:p>
+          <a:p/>
+          <a:p>
+            <a:r>
+              <a:t>STOP AT THANK YOU.</a:t>
+            </a:r>
+          </a:p>
+        </p:txBody>
+      </p:sp>
+      <p:sp>
+        <p:nvSpPr>
+          <p:cNvPr id="4" name="Slide Number Placeholder 3"/>
+          <p:cNvSpPr>
+            <a:spLocks noGrp="1"/>
+          </p:cNvSpPr>
+          <p:nvPr>
+            <p:ph type="sldNum" idx="5" sz="quarter"/>
+          </p:nvPr>
+        </p:nvSpPr>
+        <p:spPr/>
+      </p:sp>
+    </p:spTree>
+  </p:cSld>
+  <p:clrMapOvr>
+    <a:masterClrMapping/>
+  </p:clrMapOvr>
+</p:notes>
 </file>
 
 <file path=ppt/slideLayouts/slideLayout1.xml><?xml version="1.0" encoding="utf-8"?>
@@ -3139,20 +4121,104 @@
       </p:sp>
       <p:sp>
         <p:nvSpPr>
-          <p:cNvPr id="3" name="Rectangle 2"/>
+          <p:cNvPr id="3" name="TextBox 2"/>
+          <p:cNvSpPr txBox="1"/>
+          <p:nvPr/>
+        </p:nvSpPr>
+        <p:spPr>
+          <a:xfrm>
+            <a:off x="777240" y="411480"/>
+            <a:ext cx="10607040" cy="365760"/>
+          </a:xfrm>
+          <a:prstGeom prst="rect">
+            <a:avLst/>
+          </a:prstGeom>
+          <a:noFill/>
+        </p:spPr>
+        <p:txBody>
+          <a:bodyPr wrap="square" anchor="t" lIns="0" rIns="0" tIns="0" bIns="0">
+            <a:spAutoFit/>
+          </a:bodyPr>
+          <a:lstStyle/>
+          <a:p>
+            <a:pPr algn="l">
+              <a:lnSpc>
+                <a:spcPct val="100000"/>
+              </a:lnSpc>
+              <a:spcAft>
+                <a:spcPts val="600"/>
+              </a:spcAft>
+            </a:pPr>
+            <a:r>
+              <a:rPr sz="1300" b="1">
+                <a:solidFill>
+                  <a:srgbClr val="C04A12"/>
+                </a:solidFill>
+                <a:latin typeface="Calibri"/>
+              </a:rPr>
+              <a:t>MARATHON PETROLEUM  ·  SAME DATA  ·  SAME YEAR</a:t>
+            </a:r>
+          </a:p>
+        </p:txBody>
+      </p:sp>
+      <p:sp>
+        <p:nvSpPr>
+          <p:cNvPr id="4" name="TextBox 3"/>
+          <p:cNvSpPr txBox="1"/>
+          <p:nvPr/>
+        </p:nvSpPr>
+        <p:spPr>
+          <a:xfrm>
+            <a:off x="777240" y="1051560"/>
+            <a:ext cx="10607040" cy="822960"/>
+          </a:xfrm>
+          <a:prstGeom prst="rect">
+            <a:avLst/>
+          </a:prstGeom>
+          <a:noFill/>
+        </p:spPr>
+        <p:txBody>
+          <a:bodyPr wrap="square" anchor="t" lIns="0" rIns="0" tIns="0" bIns="0">
+            <a:spAutoFit/>
+          </a:bodyPr>
+          <a:lstStyle/>
+          <a:p>
+            <a:pPr algn="l">
+              <a:lnSpc>
+                <a:spcPct val="100000"/>
+              </a:lnSpc>
+              <a:spcAft>
+                <a:spcPts val="600"/>
+              </a:spcAft>
+            </a:pPr>
+            <a:r>
+              <a:rPr sz="3400" b="0">
+                <a:solidFill>
+                  <a:srgbClr val="3D3C38"/>
+                </a:solidFill>
+                <a:latin typeface="Calibri"/>
+              </a:rPr>
+              <a:t>One company. Two defensible methods.</a:t>
+            </a:r>
+          </a:p>
+        </p:txBody>
+      </p:sp>
+      <p:sp>
+        <p:nvSpPr>
+          <p:cNvPr id="5" name="Rectangle 4"/>
           <p:cNvSpPr/>
           <p:nvPr/>
         </p:nvSpPr>
         <p:spPr>
           <a:xfrm>
-            <a:off x="777240" y="1371600"/>
-            <a:ext cx="10607040" cy="50800"/>
+            <a:off x="777240" y="2057400"/>
+            <a:ext cx="5029200" cy="2651760"/>
           </a:xfrm>
           <a:prstGeom prst="rect">
             <a:avLst/>
           </a:prstGeom>
           <a:solidFill>
-            <a:srgbClr val="101010"/>
+            <a:srgbClr val="F2F1ED"/>
           </a:solidFill>
           <a:ln>
             <a:noFill/>
@@ -3183,14 +4249,14 @@
       </p:sp>
       <p:sp>
         <p:nvSpPr>
-          <p:cNvPr id="4" name="TextBox 3"/>
+          <p:cNvPr id="6" name="TextBox 5"/>
           <p:cNvSpPr txBox="1"/>
           <p:nvPr/>
         </p:nvSpPr>
         <p:spPr>
           <a:xfrm>
-            <a:off x="777240" y="1600200"/>
-            <a:ext cx="10607040" cy="1188720"/>
+            <a:off x="1097280" y="2331720"/>
+            <a:ext cx="4389120" cy="2194560"/>
           </a:xfrm>
           <a:prstGeom prst="rect">
             <a:avLst/>
@@ -3205,104 +4271,58 @@
           <a:p>
             <a:pPr algn="l">
               <a:lnSpc>
-                <a:spcPct val="100000"/>
+                <a:spcPct val="85000"/>
               </a:lnSpc>
               <a:spcAft>
-                <a:spcPts val="600"/>
+                <a:spcPts val="0"/>
               </a:spcAft>
             </a:pPr>
             <a:r>
-              <a:rPr sz="6600" b="1">
+              <a:rPr sz="12800" b="1">
                 <a:solidFill>
                   <a:srgbClr val="101010"/>
                 </a:solidFill>
                 <a:latin typeface="Calibri"/>
               </a:rPr>
-              <a:t>CONTESTED</a:t>
-            </a:r>
-          </a:p>
-        </p:txBody>
-      </p:sp>
-      <p:sp>
-        <p:nvSpPr>
-          <p:cNvPr id="5" name="TextBox 4"/>
-          <p:cNvSpPr txBox="1"/>
-          <p:nvPr/>
-        </p:nvSpPr>
-        <p:spPr>
-          <a:xfrm>
-            <a:off x="777240" y="2788920"/>
-            <a:ext cx="10607040" cy="731520"/>
-          </a:xfrm>
-          <a:prstGeom prst="rect">
-            <a:avLst/>
-          </a:prstGeom>
-          <a:noFill/>
-        </p:spPr>
-        <p:txBody>
-          <a:bodyPr wrap="square" anchor="t" lIns="0" rIns="0" tIns="0" bIns="0">
-            <a:spAutoFit/>
-          </a:bodyPr>
-          <a:lstStyle/>
+              <a:t>15</a:t>
+            </a:r>
+          </a:p>
           <a:p>
             <a:pPr algn="l">
               <a:lnSpc>
-                <a:spcPct val="100000"/>
+                <a:spcPct val="85000"/>
               </a:lnSpc>
               <a:spcAft>
-                <a:spcPts val="600"/>
+                <a:spcPts val="0"/>
               </a:spcAft>
             </a:pPr>
             <a:r>
-              <a:rPr sz="2600" b="0">
+              <a:rPr sz="2800" b="0">
                 <a:solidFill>
                   <a:srgbClr val="3D3C38"/>
                 </a:solidFill>
                 <a:latin typeface="Calibri"/>
               </a:rPr>
-              <a:t>Every ESG score is one answer to a question nobody wrote down.</a:t>
-            </a:r>
-          </a:p>
-        </p:txBody>
-      </p:sp>
-      <p:sp>
-        <p:nvSpPr>
-          <p:cNvPr id="6" name="TextBox 5"/>
-          <p:cNvSpPr txBox="1"/>
-          <p:nvPr/>
-        </p:nvSpPr>
-        <p:spPr>
-          <a:xfrm>
-            <a:off x="777240" y="3429000"/>
-            <a:ext cx="10607040" cy="731520"/>
-          </a:xfrm>
-          <a:prstGeom prst="rect">
-            <a:avLst/>
-          </a:prstGeom>
-          <a:noFill/>
-        </p:spPr>
-        <p:txBody>
-          <a:bodyPr wrap="square" anchor="t" lIns="0" rIns="0" tIns="0" bIns="0">
-            <a:spAutoFit/>
-          </a:bodyPr>
-          <a:lstStyle/>
+              <a:t>th of 18</a:t>
+            </a:r>
+          </a:p>
           <a:p>
             <a:pPr algn="l">
               <a:lnSpc>
-                <a:spcPct val="100000"/>
+                <a:spcPct val="85000"/>
               </a:lnSpc>
               <a:spcAft>
-                <a:spcPts val="600"/>
+                <a:spcPts val="0"/>
               </a:spcAft>
             </a:pPr>
             <a:r>
-              <a:rPr sz="2600" b="1">
-                <a:solidFill>
-                  <a:srgbClr val="C04A12"/>
+              <a:rPr sz="1700" b="0">
+                <a:solidFill>
+                  <a:srgbClr val="6B6A63"/>
                 </a:solidFill>
                 <a:latin typeface="Calibri"/>
               </a:rPr>
-              <a:t>We publish the question, the answer, and how much the answer depends on the question.</a:t>
+              <a:t>on how clean it is today</a:t>
             </a:r>
           </a:p>
         </p:txBody>
@@ -3315,14 +4335,14 @@
         </p:nvSpPr>
         <p:spPr>
           <a:xfrm>
-            <a:off x="777240" y="4480560"/>
-            <a:ext cx="10607040" cy="25400"/>
+            <a:off x="6355080" y="2057400"/>
+            <a:ext cx="5029200" cy="2651760"/>
           </a:xfrm>
           <a:prstGeom prst="rect">
             <a:avLst/>
           </a:prstGeom>
           <a:solidFill>
-            <a:srgbClr val="101010"/>
+            <a:srgbClr val="F2F1ED"/>
           </a:solidFill>
           <a:ln>
             <a:noFill/>
@@ -3359,8 +4379,132 @@
         </p:nvSpPr>
         <p:spPr>
           <a:xfrm>
-            <a:off x="777240" y="4709160"/>
-            <a:ext cx="10607040" cy="822960"/>
+            <a:off x="6675120" y="2331720"/>
+            <a:ext cx="4389120" cy="2194560"/>
+          </a:xfrm>
+          <a:prstGeom prst="rect">
+            <a:avLst/>
+          </a:prstGeom>
+          <a:noFill/>
+        </p:spPr>
+        <p:txBody>
+          <a:bodyPr wrap="square" anchor="t" lIns="0" rIns="0" tIns="0" bIns="0">
+            <a:spAutoFit/>
+          </a:bodyPr>
+          <a:lstStyle/>
+          <a:p>
+            <a:pPr algn="l">
+              <a:lnSpc>
+                <a:spcPct val="85000"/>
+              </a:lnSpc>
+              <a:spcAft>
+                <a:spcPts val="0"/>
+              </a:spcAft>
+            </a:pPr>
+            <a:r>
+              <a:rPr sz="12800" b="1">
+                <a:solidFill>
+                  <a:srgbClr val="C04A12"/>
+                </a:solidFill>
+                <a:latin typeface="Calibri"/>
+              </a:rPr>
+              <a:t>6</a:t>
+            </a:r>
+          </a:p>
+          <a:p>
+            <a:pPr algn="l">
+              <a:lnSpc>
+                <a:spcPct val="85000"/>
+              </a:lnSpc>
+              <a:spcAft>
+                <a:spcPts val="0"/>
+              </a:spcAft>
+            </a:pPr>
+            <a:r>
+              <a:rPr sz="2800" b="0">
+                <a:solidFill>
+                  <a:srgbClr val="C04A12"/>
+                </a:solidFill>
+                <a:latin typeface="Calibri"/>
+              </a:rPr>
+              <a:t>th of 18</a:t>
+            </a:r>
+          </a:p>
+          <a:p>
+            <a:pPr algn="l">
+              <a:lnSpc>
+                <a:spcPct val="85000"/>
+              </a:lnSpc>
+              <a:spcAft>
+                <a:spcPts val="0"/>
+              </a:spcAft>
+            </a:pPr>
+            <a:r>
+              <a:rPr sz="1700" b="0">
+                <a:solidFill>
+                  <a:srgbClr val="6B6A63"/>
+                </a:solidFill>
+                <a:latin typeface="Calibri"/>
+              </a:rPr>
+              <a:t>on how fast it is improving</a:t>
+            </a:r>
+          </a:p>
+        </p:txBody>
+      </p:sp>
+      <p:sp>
+        <p:nvSpPr>
+          <p:cNvPr id="9" name="Rectangle 8"/>
+          <p:cNvSpPr/>
+          <p:nvPr/>
+        </p:nvSpPr>
+        <p:spPr>
+          <a:xfrm>
+            <a:off x="777240" y="5029200"/>
+            <a:ext cx="10607040" cy="38100"/>
+          </a:xfrm>
+          <a:prstGeom prst="rect">
+            <a:avLst/>
+          </a:prstGeom>
+          <a:solidFill>
+            <a:srgbClr val="101010"/>
+          </a:solidFill>
+          <a:ln>
+            <a:noFill/>
+          </a:ln>
+          <a:effectLst/>
+        </p:spPr>
+        <p:style>
+          <a:lnRef idx="1">
+            <a:schemeClr val="accent1"/>
+          </a:lnRef>
+          <a:fillRef idx="3">
+            <a:schemeClr val="accent1"/>
+          </a:fillRef>
+          <a:effectRef idx="2">
+            <a:schemeClr val="accent1"/>
+          </a:effectRef>
+          <a:fontRef idx="minor">
+            <a:schemeClr val="lt1"/>
+          </a:fontRef>
+        </p:style>
+        <p:txBody>
+          <a:bodyPr rtlCol="0" anchor="ctr"/>
+          <a:lstStyle/>
+          <a:p>
+            <a:pPr algn="ctr"/>
+          </a:p>
+        </p:txBody>
+      </p:sp>
+      <p:sp>
+        <p:nvSpPr>
+          <p:cNvPr id="10" name="TextBox 9"/>
+          <p:cNvSpPr txBox="1"/>
+          <p:nvPr/>
+        </p:nvSpPr>
+        <p:spPr>
+          <a:xfrm>
+            <a:off x="777240" y="5257800"/>
+            <a:ext cx="10607040" cy="1005840"/>
           </a:xfrm>
           <a:prstGeom prst="rect">
             <a:avLst/>
@@ -3378,59 +4522,36 @@
                 <a:spcPct val="100000"/>
               </a:lnSpc>
               <a:spcAft>
-                <a:spcPts val="600"/>
+                <a:spcPts val="400"/>
               </a:spcAft>
             </a:pPr>
             <a:r>
-              <a:rPr sz="1700" b="0">
-                <a:solidFill>
-                  <a:srgbClr val="6B6A63"/>
+              <a:rPr sz="3000" b="1">
+                <a:solidFill>
+                  <a:srgbClr val="101010"/>
                 </a:solidFill>
                 <a:latin typeface="Calibri"/>
               </a:rPr>
-              <a:t>18 S&amp;P 500 Energy companies  ·  138 indicators  ·  17,496 defensible scores each  ·  live tool</a:t>
-            </a:r>
-          </a:p>
-        </p:txBody>
-      </p:sp>
-      <p:sp>
-        <p:nvSpPr>
-          <p:cNvPr id="9" name="TextBox 8"/>
-          <p:cNvSpPr txBox="1"/>
-          <p:nvPr/>
-        </p:nvSpPr>
-        <p:spPr>
-          <a:xfrm>
-            <a:off x="777240" y="6263640"/>
-            <a:ext cx="10607040" cy="365760"/>
-          </a:xfrm>
-          <a:prstGeom prst="rect">
-            <a:avLst/>
-          </a:prstGeom>
-          <a:noFill/>
-        </p:spPr>
-        <p:txBody>
-          <a:bodyPr wrap="square" anchor="t" lIns="0" rIns="0" tIns="0" bIns="0">
-            <a:spAutoFit/>
-          </a:bodyPr>
-          <a:lstStyle/>
+              <a:t>Nine places apart. Neither number is a mistake.</a:t>
+            </a:r>
+          </a:p>
           <a:p>
             <a:pPr algn="l">
               <a:lnSpc>
                 <a:spcPct val="100000"/>
               </a:lnSpc>
               <a:spcAft>
-                <a:spcPts val="600"/>
+                <a:spcPts val="400"/>
               </a:spcAft>
             </a:pPr>
             <a:r>
-              <a:rPr sz="1100" b="0">
-                <a:solidFill>
-                  <a:srgbClr val="6B6A63"/>
+              <a:rPr sz="2400" b="1">
+                <a:solidFill>
+                  <a:srgbClr val="C04A12"/>
                 </a:solidFill>
                 <a:latin typeface="Calibri"/>
               </a:rPr>
-              <a:t>ETHack 2026 · Challenge #1 · Citadel &amp; Citadel Securities</a:t>
+              <a:t>An ESG score is one answer to a question nobody wrote down.</a:t>
             </a:r>
           </a:p>
         </p:txBody>
@@ -3505,8 +4626,8 @@
         </p:nvSpPr>
         <p:spPr>
           <a:xfrm>
-            <a:off x="777240" y="457200"/>
-            <a:ext cx="10058400" cy="365760"/>
+            <a:off x="777240" y="411480"/>
+            <a:ext cx="10607040" cy="365760"/>
           </a:xfrm>
           <a:prstGeom prst="rect">
             <a:avLst/>
@@ -3534,82 +4655,21 @@
                 </a:solidFill>
                 <a:latin typeface="Calibri"/>
               </a:rPr>
-              <a:t>THE PROBLEM</a:t>
-            </a:r>
-          </a:p>
-        </p:txBody>
-      </p:sp>
-      <p:sp>
-        <p:nvSpPr>
-          <p:cNvPr id="4" name="TextBox 3"/>
-          <p:cNvSpPr txBox="1"/>
-          <p:nvPr/>
-        </p:nvSpPr>
-        <p:spPr>
-          <a:xfrm>
-            <a:off x="777240" y="914400"/>
-            <a:ext cx="10607040" cy="914400"/>
-          </a:xfrm>
-          <a:prstGeom prst="rect">
-            <a:avLst/>
-          </a:prstGeom>
-          <a:noFill/>
-        </p:spPr>
-        <p:txBody>
-          <a:bodyPr wrap="square" anchor="t" lIns="0" rIns="0" tIns="0" bIns="0">
-            <a:spAutoFit/>
-          </a:bodyPr>
-          <a:lstStyle/>
-          <a:p>
-            <a:pPr algn="l">
-              <a:lnSpc>
-                <a:spcPct val="100000"/>
-              </a:lnSpc>
-              <a:spcAft>
-                <a:spcPts val="200"/>
-              </a:spcAft>
-            </a:pPr>
-            <a:r>
-              <a:rPr sz="3800" b="1">
-                <a:solidFill>
-                  <a:srgbClr val="101010"/>
-                </a:solidFill>
-                <a:latin typeface="Calibri"/>
-              </a:rPr>
-              <a:t>The market buys a point estimate of a quantity</a:t>
-            </a:r>
-          </a:p>
-          <a:p>
-            <a:pPr algn="l">
-              <a:lnSpc>
-                <a:spcPct val="100000"/>
-              </a:lnSpc>
-              <a:spcAft>
-                <a:spcPts val="200"/>
-              </a:spcAft>
-            </a:pPr>
-            <a:r>
-              <a:rPr sz="3800" b="1">
-                <a:solidFill>
-                  <a:srgbClr val="C04A12"/>
-                </a:solidFill>
-                <a:latin typeface="Calibri"/>
-              </a:rPr>
-              <a:t>that has no point estimate.</a:t>
-            </a:r>
-          </a:p>
-        </p:txBody>
-      </p:sp>
-      <p:sp>
-        <p:nvSpPr>
-          <p:cNvPr id="5" name="Rectangle 4"/>
+              <a:t>WHAT WE MEASURE, AND WHY THE INDUSTRY DISAGREES</a:t>
+            </a:r>
+          </a:p>
+        </p:txBody>
+      </p:sp>
+      <p:sp>
+        <p:nvSpPr>
+          <p:cNvPr id="4" name="Rectangle 3"/>
           <p:cNvSpPr/>
           <p:nvPr/>
         </p:nvSpPr>
         <p:spPr>
           <a:xfrm>
-            <a:off x="777240" y="2468880"/>
-            <a:ext cx="3246120" cy="1691640"/>
+            <a:off x="777240" y="914400"/>
+            <a:ext cx="5120640" cy="2148840"/>
           </a:xfrm>
           <a:prstGeom prst="rect">
             <a:avLst/>
@@ -3646,14 +4706,14 @@
       </p:sp>
       <p:sp>
         <p:nvSpPr>
-          <p:cNvPr id="6" name="TextBox 5"/>
+          <p:cNvPr id="5" name="TextBox 4"/>
           <p:cNvSpPr txBox="1"/>
           <p:nvPr/>
         </p:nvSpPr>
         <p:spPr>
           <a:xfrm>
-            <a:off x="1051560" y="2697480"/>
-            <a:ext cx="2743200" cy="731520"/>
+            <a:off x="1051560" y="1115568"/>
+            <a:ext cx="4572000" cy="1828800"/>
           </a:xfrm>
           <a:prstGeom prst="rect">
             <a:avLst/>
@@ -3668,85 +4728,71 @@
           <a:p>
             <a:pPr algn="l">
               <a:lnSpc>
-                <a:spcPct val="100000"/>
+                <a:spcPct val="110000"/>
               </a:lnSpc>
               <a:spcAft>
                 <a:spcPts val="600"/>
               </a:spcAft>
             </a:pPr>
             <a:r>
-              <a:rPr sz="5200" b="1">
-                <a:solidFill>
-                  <a:srgbClr val="3D3C38"/>
+              <a:rPr sz="1300" b="1">
+                <a:solidFill>
+                  <a:srgbClr val="C04A12"/>
                 </a:solidFill>
                 <a:latin typeface="Calibri"/>
               </a:rPr>
-              <a:t>0.99</a:t>
-            </a:r>
-          </a:p>
-        </p:txBody>
-      </p:sp>
-      <p:sp>
-        <p:nvSpPr>
-          <p:cNvPr id="7" name="TextBox 6"/>
-          <p:cNvSpPr txBox="1"/>
-          <p:nvPr/>
-        </p:nvSpPr>
-        <p:spPr>
-          <a:xfrm>
-            <a:off x="1051560" y="3520440"/>
-            <a:ext cx="2743200" cy="548640"/>
-          </a:xfrm>
-          <a:prstGeom prst="rect">
-            <a:avLst/>
-          </a:prstGeom>
-          <a:noFill/>
-        </p:spPr>
-        <p:txBody>
-          <a:bodyPr wrap="square" anchor="t" lIns="0" rIns="0" tIns="0" bIns="0">
-            <a:spAutoFit/>
-          </a:bodyPr>
-          <a:lstStyle/>
+              <a:t>Our definition</a:t>
+            </a:r>
+          </a:p>
           <a:p>
             <a:pPr algn="l">
               <a:lnSpc>
-                <a:spcPct val="100000"/>
+                <a:spcPct val="110000"/>
               </a:lnSpc>
               <a:spcAft>
                 <a:spcPts val="600"/>
               </a:spcAft>
             </a:pPr>
             <a:r>
-              <a:rPr sz="1500" b="0">
-                <a:solidFill>
-                  <a:srgbClr val="3D3C38"/>
+              <a:rPr sz="1700" b="0">
+                <a:solidFill>
+                  <a:srgbClr val="101010"/>
                 </a:solidFill>
                 <a:latin typeface="Calibri"/>
               </a:rPr>
-              <a:t>credit ratings agree</a:t>
-            </a:r>
-          </a:p>
-        </p:txBody>
-      </p:sp>
-      <p:sp>
-        <p:nvSpPr>
-          <p:cNvPr id="8" name="Rectangle 7"/>
+              <a:t>Less irreversible harm per unit of output than the peers making the same product, </a:t>
+            </a:r>
+            <a:r>
+              <a:rPr sz="1700" b="1">
+                <a:solidFill>
+                  <a:srgbClr val="101010"/>
+                </a:solidFill>
+                <a:latin typeface="Calibri"/>
+              </a:rPr>
+              <a:t>and a balance sheet that survives the transition.</a:t>
+            </a:r>
+          </a:p>
+        </p:txBody>
+      </p:sp>
+      <p:sp>
+        <p:nvSpPr>
+          <p:cNvPr id="6" name="Rectangle 5"/>
           <p:cNvSpPr/>
           <p:nvPr/>
         </p:nvSpPr>
         <p:spPr>
           <a:xfrm>
-            <a:off x="4389120" y="2468880"/>
-            <a:ext cx="3246120" cy="1691640"/>
+            <a:off x="777240" y="3246120"/>
+            <a:ext cx="5120640" cy="2651760"/>
           </a:xfrm>
           <a:prstGeom prst="rect">
             <a:avLst/>
           </a:prstGeom>
-          <a:solidFill>
-            <a:srgbClr val="F2F1ED"/>
-          </a:solidFill>
-          <a:ln>
-            <a:noFill/>
+          <a:noFill/>
+          <a:ln w="19050">
+            <a:solidFill>
+              <a:srgbClr val="101010"/>
+            </a:solidFill>
           </a:ln>
           <a:effectLst/>
         </p:spPr>
@@ -3774,14 +4820,14 @@
       </p:sp>
       <p:sp>
         <p:nvSpPr>
-          <p:cNvPr id="9" name="TextBox 8"/>
+          <p:cNvPr id="7" name="TextBox 6"/>
           <p:cNvSpPr txBox="1"/>
           <p:nvPr/>
         </p:nvSpPr>
         <p:spPr>
           <a:xfrm>
-            <a:off x="4663440" y="2697480"/>
-            <a:ext cx="2743200" cy="731520"/>
+            <a:off x="1051560" y="3429000"/>
+            <a:ext cx="4572000" cy="365760"/>
           </a:xfrm>
           <a:prstGeom prst="rect">
             <a:avLst/>
@@ -3803,13 +4849,115 @@
               </a:spcAft>
             </a:pPr>
             <a:r>
-              <a:rPr sz="5200" b="1">
+              <a:rPr sz="1300" b="1">
                 <a:solidFill>
                   <a:srgbClr val="C04A12"/>
                 </a:solidFill>
                 <a:latin typeface="Calibri"/>
               </a:rPr>
-              <a:t>0.61</a:t>
+              <a:t>Why ratings disagree</a:t>
+            </a:r>
+          </a:p>
+        </p:txBody>
+      </p:sp>
+      <p:sp>
+        <p:nvSpPr>
+          <p:cNvPr id="8" name="TextBox 7"/>
+          <p:cNvSpPr txBox="1"/>
+          <p:nvPr/>
+        </p:nvSpPr>
+        <p:spPr>
+          <a:xfrm>
+            <a:off x="1051560" y="3886200"/>
+            <a:ext cx="4572000" cy="502920"/>
+          </a:xfrm>
+          <a:prstGeom prst="rect">
+            <a:avLst/>
+          </a:prstGeom>
+          <a:noFill/>
+        </p:spPr>
+        <p:txBody>
+          <a:bodyPr wrap="square" anchor="t" lIns="0" rIns="0" tIns="0" bIns="0">
+            <a:spAutoFit/>
+          </a:bodyPr>
+          <a:lstStyle/>
+          <a:p>
+            <a:pPr algn="l">
+              <a:lnSpc>
+                <a:spcPct val="100000"/>
+              </a:lnSpc>
+              <a:spcAft>
+                <a:spcPts val="0"/>
+              </a:spcAft>
+            </a:pPr>
+            <a:r>
+              <a:rPr sz="2600" b="1">
+                <a:solidFill>
+                  <a:srgbClr val="C04A12"/>
+                </a:solidFill>
+                <a:latin typeface="Calibri"/>
+              </a:rPr>
+              <a:t>56%</a:t>
+            </a:r>
+            <a:r>
+              <a:rPr sz="1300" b="0">
+                <a:solidFill>
+                  <a:srgbClr val="101010"/>
+                </a:solidFill>
+                <a:latin typeface="Calibri"/>
+              </a:rPr>
+              <a:t>   measurement  ·  same thing, measured differently</a:t>
+            </a:r>
+          </a:p>
+        </p:txBody>
+      </p:sp>
+      <p:sp>
+        <p:nvSpPr>
+          <p:cNvPr id="9" name="TextBox 8"/>
+          <p:cNvSpPr txBox="1"/>
+          <p:nvPr/>
+        </p:nvSpPr>
+        <p:spPr>
+          <a:xfrm>
+            <a:off x="1051560" y="4453128"/>
+            <a:ext cx="4572000" cy="502920"/>
+          </a:xfrm>
+          <a:prstGeom prst="rect">
+            <a:avLst/>
+          </a:prstGeom>
+          <a:noFill/>
+        </p:spPr>
+        <p:txBody>
+          <a:bodyPr wrap="square" anchor="t" lIns="0" rIns="0" tIns="0" bIns="0">
+            <a:spAutoFit/>
+          </a:bodyPr>
+          <a:lstStyle/>
+          <a:p>
+            <a:pPr algn="l">
+              <a:lnSpc>
+                <a:spcPct val="100000"/>
+              </a:lnSpc>
+              <a:spcAft>
+                <a:spcPts val="0"/>
+              </a:spcAft>
+            </a:pPr>
+            <a:r>
+              <a:rPr sz="2600" b="1">
+                <a:solidFill>
+                  <a:srgbClr val="C04A12"/>
+                </a:solidFill>
+                <a:latin typeface="Calibri"/>
+              </a:rPr>
+              <a:t>38%</a:t>
+            </a:r>
+            <a:r>
+              <a:rPr sz="1300" b="0">
+                <a:solidFill>
+                  <a:srgbClr val="101010"/>
+                </a:solidFill>
+                <a:latin typeface="Calibri"/>
+              </a:rPr>
+              <a:t>   scope  ·  what counts at all</a:t>
             </a:r>
           </a:p>
         </p:txBody>
@@ -3822,8 +4970,59 @@
         </p:nvSpPr>
         <p:spPr>
           <a:xfrm>
-            <a:off x="4663440" y="3520440"/>
-            <a:ext cx="2743200" cy="548640"/>
+            <a:off x="1051560" y="5020056"/>
+            <a:ext cx="4572000" cy="502920"/>
+          </a:xfrm>
+          <a:prstGeom prst="rect">
+            <a:avLst/>
+          </a:prstGeom>
+          <a:noFill/>
+        </p:spPr>
+        <p:txBody>
+          <a:bodyPr wrap="square" anchor="t" lIns="0" rIns="0" tIns="0" bIns="0">
+            <a:spAutoFit/>
+          </a:bodyPr>
+          <a:lstStyle/>
+          <a:p>
+            <a:pPr algn="l">
+              <a:lnSpc>
+                <a:spcPct val="100000"/>
+              </a:lnSpc>
+              <a:spcAft>
+                <a:spcPts val="0"/>
+              </a:spcAft>
+            </a:pPr>
+            <a:r>
+              <a:rPr sz="2600" b="1">
+                <a:solidFill>
+                  <a:srgbClr val="6B6A63"/>
+                </a:solidFill>
+                <a:latin typeface="Calibri"/>
+              </a:rPr>
+              <a:t>6%</a:t>
+            </a:r>
+            <a:r>
+              <a:rPr sz="1300" b="0">
+                <a:solidFill>
+                  <a:srgbClr val="6B6A63"/>
+                </a:solidFill>
+                <a:latin typeface="Calibri"/>
+              </a:rPr>
+              <a:t>   weights  ·  the slider everyone argues about</a:t>
+            </a:r>
+          </a:p>
+        </p:txBody>
+      </p:sp>
+      <p:sp>
+        <p:nvSpPr>
+          <p:cNvPr id="11" name="TextBox 10"/>
+          <p:cNvSpPr txBox="1"/>
+          <p:nvPr/>
+        </p:nvSpPr>
+        <p:spPr>
+          <a:xfrm>
+            <a:off x="1051560" y="5532120"/>
+            <a:ext cx="4572000" cy="320040"/>
           </a:xfrm>
           <a:prstGeom prst="rect">
             <a:avLst/>
@@ -3845,71 +5044,51 @@
               </a:spcAft>
             </a:pPr>
             <a:r>
-              <a:rPr sz="1500" b="0">
-                <a:solidFill>
-                  <a:srgbClr val="3D3C38"/>
+              <a:rPr sz="1000" b="0">
+                <a:solidFill>
+                  <a:srgbClr val="6B6A63"/>
                 </a:solidFill>
                 <a:latin typeface="Calibri"/>
               </a:rPr>
-              <a:t>ESG ratings agree</a:t>
-            </a:r>
-          </a:p>
-        </p:txBody>
-      </p:sp>
-      <p:sp>
-        <p:nvSpPr>
-          <p:cNvPr id="11" name="Rectangle 10"/>
-          <p:cNvSpPr/>
+              <a:t>Berg, Kolbel &amp; Rigobon, Review of Finance 2022</a:t>
+            </a:r>
+          </a:p>
+        </p:txBody>
+      </p:sp>
+      <p:pic>
+        <p:nvPicPr>
+          <p:cNvPr id="12" name="Picture 11" descr="f1_two_questions.png"/>
+          <p:cNvPicPr>
+            <a:picLocks noChangeAspect="1"/>
+          </p:cNvPicPr>
           <p:nvPr/>
-        </p:nvSpPr>
-        <p:spPr>
-          <a:xfrm>
-            <a:off x="8001000" y="2468880"/>
-            <a:ext cx="3246120" cy="1691640"/>
+        </p:nvPicPr>
+        <p:blipFill>
+          <a:blip r:embed="rId2"/>
+          <a:stretch>
+            <a:fillRect/>
+          </a:stretch>
+        </p:blipFill>
+        <p:spPr>
+          <a:xfrm>
+            <a:off x="6172200" y="960120"/>
+            <a:ext cx="5486400" cy="2590800"/>
           </a:xfrm>
           <a:prstGeom prst="rect">
             <a:avLst/>
           </a:prstGeom>
-          <a:solidFill>
-            <a:srgbClr val="F2F1ED"/>
-          </a:solidFill>
-          <a:ln>
-            <a:noFill/>
-          </a:ln>
-          <a:effectLst/>
-        </p:spPr>
-        <p:style>
-          <a:lnRef idx="1">
-            <a:schemeClr val="accent1"/>
-          </a:lnRef>
-          <a:fillRef idx="3">
-            <a:schemeClr val="accent1"/>
-          </a:fillRef>
-          <a:effectRef idx="2">
-            <a:schemeClr val="accent1"/>
-          </a:effectRef>
-          <a:fontRef idx="minor">
-            <a:schemeClr val="lt1"/>
-          </a:fontRef>
-        </p:style>
-        <p:txBody>
-          <a:bodyPr rtlCol="0" anchor="ctr"/>
-          <a:lstStyle/>
-          <a:p>
-            <a:pPr algn="ctr"/>
-          </a:p>
-        </p:txBody>
-      </p:sp>
-      <p:sp>
-        <p:nvSpPr>
-          <p:cNvPr id="12" name="TextBox 11"/>
+        </p:spPr>
+      </p:pic>
+      <p:sp>
+        <p:nvSpPr>
+          <p:cNvPr id="13" name="TextBox 12"/>
           <p:cNvSpPr txBox="1"/>
           <p:nvPr/>
         </p:nvSpPr>
         <p:spPr>
           <a:xfrm>
-            <a:off x="8275320" y="2697480"/>
-            <a:ext cx="2743200" cy="731520"/>
+            <a:off x="6172200" y="5029200"/>
+            <a:ext cx="5486400" cy="822960"/>
           </a:xfrm>
           <a:prstGeom prst="rect">
             <a:avLst/>
@@ -3924,155 +5103,39 @@
           <a:p>
             <a:pPr algn="l">
               <a:lnSpc>
-                <a:spcPct val="100000"/>
+                <a:spcPct val="110000"/>
               </a:lnSpc>
               <a:spcAft>
-                <a:spcPts val="600"/>
+                <a:spcPts val="300"/>
               </a:spcAft>
             </a:pPr>
             <a:r>
-              <a:rPr sz="5200" b="1">
-                <a:solidFill>
-                  <a:srgbClr val="3D3C38"/>
+              <a:rPr sz="1500" b="1">
+                <a:solidFill>
+                  <a:srgbClr val="101010"/>
                 </a:solidFill>
                 <a:latin typeface="Calibri"/>
               </a:rPr>
-              <a:t>6%</a:t>
-            </a:r>
-          </a:p>
-        </p:txBody>
-      </p:sp>
-      <p:sp>
-        <p:nvSpPr>
-          <p:cNvPr id="13" name="TextBox 12"/>
-          <p:cNvSpPr txBox="1"/>
-          <p:nvPr/>
-        </p:nvSpPr>
-        <p:spPr>
-          <a:xfrm>
-            <a:off x="8275320" y="3520440"/>
-            <a:ext cx="2743200" cy="548640"/>
-          </a:xfrm>
-          <a:prstGeom prst="rect">
-            <a:avLst/>
-          </a:prstGeom>
-          <a:noFill/>
-        </p:spPr>
-        <p:txBody>
-          <a:bodyPr wrap="square" anchor="t" lIns="0" rIns="0" tIns="0" bIns="0">
-            <a:spAutoFit/>
-          </a:bodyPr>
-          <a:lstStyle/>
+              <a:t>All 18 companies, both questions.</a:t>
+            </a:r>
+          </a:p>
           <a:p>
             <a:pPr algn="l">
               <a:lnSpc>
-                <a:spcPct val="100000"/>
+                <a:spcPct val="110000"/>
               </a:lnSpc>
               <a:spcAft>
-                <a:spcPts val="600"/>
+                <a:spcPts val="300"/>
               </a:spcAft>
             </a:pPr>
             <a:r>
-              <a:rPr sz="1500" b="0">
-                <a:solidFill>
-                  <a:srgbClr val="3D3C38"/>
+              <a:rPr sz="1300" b="0">
+                <a:solidFill>
+                  <a:srgbClr val="6B6A63"/>
                 </a:solidFill>
                 <a:latin typeface="Calibri"/>
               </a:rPr>
-              <a:t>of the gap is pillar weights</a:t>
-            </a:r>
-          </a:p>
-        </p:txBody>
-      </p:sp>
-      <p:sp>
-        <p:nvSpPr>
-          <p:cNvPr id="14" name="TextBox 13"/>
-          <p:cNvSpPr txBox="1"/>
-          <p:nvPr/>
-        </p:nvSpPr>
-        <p:spPr>
-          <a:xfrm>
-            <a:off x="777240" y="4526280"/>
-            <a:ext cx="10607040" cy="1280160"/>
-          </a:xfrm>
-          <a:prstGeom prst="rect">
-            <a:avLst/>
-          </a:prstGeom>
-          <a:noFill/>
-        </p:spPr>
-        <p:txBody>
-          <a:bodyPr wrap="square" anchor="t" lIns="0" rIns="0" tIns="0" bIns="0">
-            <a:spAutoFit/>
-          </a:bodyPr>
-          <a:lstStyle/>
-          <a:p>
-            <a:pPr algn="l">
-              <a:lnSpc>
-                <a:spcPct val="125000"/>
-              </a:lnSpc>
-              <a:spcAft>
-                <a:spcPts val="600"/>
-              </a:spcAft>
-            </a:pPr>
-            <a:r>
-              <a:rPr sz="2000" b="0">
-                <a:solidFill>
-                  <a:srgbClr val="3D3C38"/>
-                </a:solidFill>
-                <a:latin typeface="Calibri"/>
-              </a:rPr>
-              <a:t>Providers compute a distribution over method choices, publish one draw, and throw the rest away. </a:t>
-            </a:r>
-            <a:r>
-              <a:rPr sz="2000" b="1">
-                <a:solidFill>
-                  <a:srgbClr val="101010"/>
-                </a:solidFill>
-                <a:latin typeface="Calibri"/>
-              </a:rPr>
-              <a:t>The thrown-away part is the part an allocator needs.</a:t>
-            </a:r>
-          </a:p>
-        </p:txBody>
-      </p:sp>
-      <p:sp>
-        <p:nvSpPr>
-          <p:cNvPr id="15" name="TextBox 14"/>
-          <p:cNvSpPr txBox="1"/>
-          <p:nvPr/>
-        </p:nvSpPr>
-        <p:spPr>
-          <a:xfrm>
-            <a:off x="777240" y="6263640"/>
-            <a:ext cx="10607040" cy="365760"/>
-          </a:xfrm>
-          <a:prstGeom prst="rect">
-            <a:avLst/>
-          </a:prstGeom>
-          <a:noFill/>
-        </p:spPr>
-        <p:txBody>
-          <a:bodyPr wrap="square" anchor="t" lIns="0" rIns="0" tIns="0" bIns="0">
-            <a:spAutoFit/>
-          </a:bodyPr>
-          <a:lstStyle/>
-          <a:p>
-            <a:pPr algn="l">
-              <a:lnSpc>
-                <a:spcPct val="100000"/>
-              </a:lnSpc>
-              <a:spcAft>
-                <a:spcPts val="600"/>
-              </a:spcAft>
-            </a:pPr>
-            <a:r>
-              <a:rPr sz="1100" b="0">
-                <a:solidFill>
-                  <a:srgbClr val="6B6A63"/>
-                </a:solidFill>
-                <a:latin typeface="Calibri"/>
-              </a:rPr>
-              <a:t>Berg, Kölbel &amp; Rigobon, Review of Finance 2022. Divergence: measurement 56%, scope 38%, weights 6%.</a:t>
+              <a:t>Blue is where they stand. Orange is where they are heading. The bars are how far the answer moves on method choice alone.</a:t>
             </a:r>
           </a:p>
         </p:txBody>
@@ -4147,8 +5210,8 @@
         </p:nvSpPr>
         <p:spPr>
           <a:xfrm>
-            <a:off x="777240" y="457200"/>
-            <a:ext cx="10058400" cy="365760"/>
+            <a:off x="777240" y="411480"/>
+            <a:ext cx="10607040" cy="365760"/>
           </a:xfrm>
           <a:prstGeom prst="rect">
             <a:avLst/>
@@ -4176,7 +5239,7 @@
                 </a:solidFill>
                 <a:latin typeface="Calibri"/>
               </a:rPr>
-              <a:t>WHAT WE BUILT</a:t>
+              <a:t>WHY THE ENERGY SECTOR</a:t>
             </a:r>
           </a:p>
         </p:txBody>
@@ -4189,8 +5252,8 @@
         </p:nvSpPr>
         <p:spPr>
           <a:xfrm>
-            <a:off x="777240" y="868680"/>
-            <a:ext cx="10607040" cy="685800"/>
+            <a:off x="777240" y="914400"/>
+            <a:ext cx="10607040" cy="731520"/>
           </a:xfrm>
           <a:prstGeom prst="rect">
             <a:avLst/>
@@ -4212,78 +5275,27 @@
               </a:spcAft>
             </a:pPr>
             <a:r>
-              <a:rPr sz="2900" b="0">
+              <a:rPr sz="3000" b="1">
                 <a:solidFill>
                   <a:srgbClr val="101010"/>
                 </a:solidFill>
                 <a:latin typeface="Calibri"/>
               </a:rPr>
-              <a:t>We read MSCI's and Bloomberg's methodologies and found </a:t>
-            </a:r>
-            <a:r>
-              <a:rPr sz="2900" b="1">
-                <a:solidFill>
-                  <a:srgbClr val="101010"/>
-                </a:solidFill>
-                <a:latin typeface="Calibri"/>
-              </a:rPr>
-              <a:t>13 places a rater must choose.</a:t>
-            </a:r>
-          </a:p>
-        </p:txBody>
-      </p:sp>
-      <p:sp>
-        <p:nvSpPr>
-          <p:cNvPr id="5" name="TextBox 4"/>
-          <p:cNvSpPr txBox="1"/>
-          <p:nvPr/>
-        </p:nvSpPr>
-        <p:spPr>
-          <a:xfrm>
-            <a:off x="777240" y="1508760"/>
-            <a:ext cx="10607040" cy="502920"/>
-          </a:xfrm>
-          <a:prstGeom prst="rect">
-            <a:avLst/>
-          </a:prstGeom>
-          <a:noFill/>
-        </p:spPr>
-        <p:txBody>
-          <a:bodyPr wrap="square" anchor="t" lIns="0" rIns="0" tIns="0" bIns="0">
-            <a:spAutoFit/>
-          </a:bodyPr>
-          <a:lstStyle/>
-          <a:p>
-            <a:pPr algn="l">
-              <a:lnSpc>
-                <a:spcPct val="100000"/>
-              </a:lnSpc>
-              <a:spcAft>
-                <a:spcPts val="600"/>
-              </a:spcAft>
-            </a:pPr>
-            <a:r>
-              <a:rPr sz="1900" b="0">
-                <a:solidFill>
-                  <a:srgbClr val="3D3C38"/>
-                </a:solidFill>
-                <a:latin typeface="Calibri"/>
-              </a:rPr>
-              <a:t>They differ at seven. We vary those, fix the rest, and declare every assumption.</a:t>
-            </a:r>
-          </a:p>
-        </p:txBody>
-      </p:sp>
-      <p:sp>
-        <p:nvSpPr>
-          <p:cNvPr id="6" name="Rectangle 5"/>
+              <a:t>The hardest place to score, so the best place to test.</a:t>
+            </a:r>
+          </a:p>
+        </p:txBody>
+      </p:sp>
+      <p:sp>
+        <p:nvSpPr>
+          <p:cNvPr id="5" name="Rectangle 4"/>
           <p:cNvSpPr/>
           <p:nvPr/>
         </p:nvSpPr>
         <p:spPr>
           <a:xfrm>
-            <a:off x="777240" y="2240280"/>
-            <a:ext cx="3246120" cy="868680"/>
+            <a:off x="777240" y="1965960"/>
+            <a:ext cx="5074920" cy="1143000"/>
           </a:xfrm>
           <a:prstGeom prst="rect">
             <a:avLst/>
@@ -4320,14 +5332,14 @@
       </p:sp>
       <p:sp>
         <p:nvSpPr>
-          <p:cNvPr id="7" name="TextBox 6"/>
+          <p:cNvPr id="6" name="TextBox 5"/>
           <p:cNvSpPr txBox="1"/>
           <p:nvPr/>
         </p:nvSpPr>
         <p:spPr>
           <a:xfrm>
-            <a:off x="978408" y="2359152"/>
-            <a:ext cx="2926080" cy="320040"/>
+            <a:off x="1051560" y="2130552"/>
+            <a:ext cx="4572000" cy="411480"/>
           </a:xfrm>
           <a:prstGeom prst="rect">
             <a:avLst/>
@@ -4349,27 +5361,27 @@
               </a:spcAft>
             </a:pPr>
             <a:r>
-              <a:rPr sz="1500" b="1">
-                <a:solidFill>
-                  <a:srgbClr val="101010"/>
+              <a:rPr sz="2200" b="1">
+                <a:solidFill>
+                  <a:srgbClr val="C04A12"/>
                 </a:solidFill>
                 <a:latin typeface="Calibri"/>
               </a:rPr>
-              <a:t>Exposure base</a:t>
-            </a:r>
-          </a:p>
-        </p:txBody>
-      </p:sp>
-      <p:sp>
-        <p:nvSpPr>
-          <p:cNvPr id="8" name="TextBox 7"/>
+              <a:t>Only 3 of 37</a:t>
+            </a:r>
+          </a:p>
+        </p:txBody>
+      </p:sp>
+      <p:sp>
+        <p:nvSpPr>
+          <p:cNvPr id="7" name="TextBox 6"/>
           <p:cNvSpPr txBox="1"/>
           <p:nvPr/>
         </p:nvSpPr>
         <p:spPr>
           <a:xfrm>
-            <a:off x="978408" y="2697480"/>
-            <a:ext cx="2926080" cy="320040"/>
+            <a:off x="1051560" y="2624328"/>
+            <a:ext cx="4572000" cy="411480"/>
           </a:xfrm>
           <a:prstGeom prst="rect">
             <a:avLst/>
@@ -4391,27 +5403,27 @@
               </a:spcAft>
             </a:pPr>
             <a:r>
-              <a:rPr sz="1200" b="0">
-                <a:solidFill>
-                  <a:srgbClr val="6B6A63"/>
+              <a:rPr sz="1400" b="0">
+                <a:solidFill>
+                  <a:srgbClr val="3D3C38"/>
                 </a:solidFill>
                 <a:latin typeface="Calibri"/>
               </a:rPr>
-              <a:t>EBITDA · equity · output</a:t>
-            </a:r>
-          </a:p>
-        </p:txBody>
-      </p:sp>
-      <p:sp>
-        <p:nvSpPr>
-          <p:cNvPr id="9" name="Rectangle 8"/>
+              <a:t>environmental fields are reported by all 18 companies</a:t>
+            </a:r>
+          </a:p>
+        </p:txBody>
+      </p:sp>
+      <p:sp>
+        <p:nvSpPr>
+          <p:cNvPr id="8" name="Rectangle 7"/>
           <p:cNvSpPr/>
           <p:nvPr/>
         </p:nvSpPr>
         <p:spPr>
           <a:xfrm>
-            <a:off x="4389120" y="2240280"/>
-            <a:ext cx="3246120" cy="868680"/>
+            <a:off x="6217920" y="1965960"/>
+            <a:ext cx="5074920" cy="1143000"/>
           </a:xfrm>
           <a:prstGeom prst="rect">
             <a:avLst/>
@@ -4448,14 +5460,14 @@
       </p:sp>
       <p:sp>
         <p:nvSpPr>
-          <p:cNvPr id="10" name="TextBox 9"/>
+          <p:cNvPr id="9" name="TextBox 8"/>
           <p:cNvSpPr txBox="1"/>
           <p:nvPr/>
         </p:nvSpPr>
         <p:spPr>
           <a:xfrm>
-            <a:off x="4590288" y="2359152"/>
-            <a:ext cx="2926080" cy="320040"/>
+            <a:off x="6492240" y="2130552"/>
+            <a:ext cx="4572000" cy="411480"/>
           </a:xfrm>
           <a:prstGeom prst="rect">
             <a:avLst/>
@@ -4477,27 +5489,27 @@
               </a:spcAft>
             </a:pPr>
             <a:r>
-              <a:rPr sz="1500" b="1">
-                <a:solidFill>
-                  <a:srgbClr val="101010"/>
+              <a:rPr sz="2200" b="1">
+                <a:solidFill>
+                  <a:srgbClr val="C04A12"/>
                 </a:solidFill>
                 <a:latin typeface="Calibri"/>
               </a:rPr>
-              <a:t>Normaliser</a:t>
-            </a:r>
-          </a:p>
-        </p:txBody>
-      </p:sp>
-      <p:sp>
-        <p:nvSpPr>
-          <p:cNvPr id="11" name="TextBox 10"/>
+              <a:t>Scope 3 absent</a:t>
+            </a:r>
+          </a:p>
+        </p:txBody>
+      </p:sp>
+      <p:sp>
+        <p:nvSpPr>
+          <p:cNvPr id="10" name="TextBox 9"/>
           <p:cNvSpPr txBox="1"/>
           <p:nvPr/>
         </p:nvSpPr>
         <p:spPr>
           <a:xfrm>
-            <a:off x="4590288" y="2697480"/>
-            <a:ext cx="2926080" cy="320040"/>
+            <a:off x="6492240" y="2624328"/>
+            <a:ext cx="4572000" cy="411480"/>
           </a:xfrm>
           <a:prstGeom prst="rect">
             <a:avLst/>
@@ -4519,27 +5531,27 @@
               </a:spcAft>
             </a:pPr>
             <a:r>
-              <a:rPr sz="1200" b="0">
-                <a:solidFill>
-                  <a:srgbClr val="6B6A63"/>
+              <a:rPr sz="1400" b="0">
+                <a:solidFill>
+                  <a:srgbClr val="3D3C38"/>
                 </a:solidFill>
                 <a:latin typeface="Calibri"/>
               </a:rPr>
-              <a:t>percentile · winsorised · log · elasticity</a:t>
-            </a:r>
-          </a:p>
-        </p:txBody>
-      </p:sp>
-      <p:sp>
-        <p:nvSpPr>
-          <p:cNvPr id="12" name="Rectangle 11"/>
+              <a:t>from every field Bloomberg delivers for these peer groups</a:t>
+            </a:r>
+          </a:p>
+        </p:txBody>
+      </p:sp>
+      <p:sp>
+        <p:nvSpPr>
+          <p:cNvPr id="11" name="Rectangle 10"/>
           <p:cNvSpPr/>
           <p:nvPr/>
         </p:nvSpPr>
         <p:spPr>
           <a:xfrm>
-            <a:off x="8001000" y="2240280"/>
-            <a:ext cx="3246120" cy="868680"/>
+            <a:off x="777240" y="3337560"/>
+            <a:ext cx="5074920" cy="1143000"/>
           </a:xfrm>
           <a:prstGeom prst="rect">
             <a:avLst/>
@@ -4576,14 +5588,14 @@
       </p:sp>
       <p:sp>
         <p:nvSpPr>
-          <p:cNvPr id="13" name="TextBox 12"/>
+          <p:cNvPr id="12" name="TextBox 11"/>
           <p:cNvSpPr txBox="1"/>
           <p:nvPr/>
         </p:nvSpPr>
         <p:spPr>
           <a:xfrm>
-            <a:off x="8202168" y="2359152"/>
-            <a:ext cx="2926080" cy="320040"/>
+            <a:off x="1051560" y="3502152"/>
+            <a:ext cx="4572000" cy="411480"/>
           </a:xfrm>
           <a:prstGeom prst="rect">
             <a:avLst/>
@@ -4605,27 +5617,27 @@
               </a:spcAft>
             </a:pPr>
             <a:r>
-              <a:rPr sz="1500" b="1">
-                <a:solidFill>
-                  <a:srgbClr val="101010"/>
+              <a:rPr sz="2200" b="1">
+                <a:solidFill>
+                  <a:srgbClr val="C04A12"/>
                 </a:solidFill>
                 <a:latin typeface="Calibri"/>
               </a:rPr>
-              <a:t>Evidence bar</a:t>
-            </a:r>
-          </a:p>
-        </p:txBody>
-      </p:sp>
-      <p:sp>
-        <p:nvSpPr>
-          <p:cNvPr id="14" name="TextBox 13"/>
+              <a:t>FY2025 is 36%</a:t>
+            </a:r>
+          </a:p>
+        </p:txBody>
+      </p:sp>
+      <p:sp>
+        <p:nvSpPr>
+          <p:cNvPr id="13" name="TextBox 12"/>
           <p:cNvSpPr txBox="1"/>
           <p:nvPr/>
         </p:nvSpPr>
         <p:spPr>
           <a:xfrm>
-            <a:off x="8202168" y="2697480"/>
-            <a:ext cx="2926080" cy="320040"/>
+            <a:off x="1051560" y="3995928"/>
+            <a:ext cx="4572000" cy="411480"/>
           </a:xfrm>
           <a:prstGeom prst="rect">
             <a:avLst/>
@@ -4647,27 +5659,27 @@
               </a:spcAft>
             </a:pPr>
             <a:r>
-              <a:rPr sz="1200" b="0">
-                <a:solidFill>
-                  <a:srgbClr val="6B6A63"/>
+              <a:rPr sz="1400" b="0">
+                <a:solidFill>
+                  <a:srgbClr val="3D3C38"/>
                 </a:solidFill>
                 <a:latin typeface="Calibri"/>
               </a:rPr>
-              <a:t>permissive · majority · strict</a:t>
-            </a:r>
-          </a:p>
-        </p:txBody>
-      </p:sp>
-      <p:sp>
-        <p:nvSpPr>
-          <p:cNvPr id="15" name="Rectangle 14"/>
+              <a:t>complete for environmental data. The lag is structural</a:t>
+            </a:r>
+          </a:p>
+        </p:txBody>
+      </p:sp>
+      <p:sp>
+        <p:nvSpPr>
+          <p:cNvPr id="14" name="Rectangle 13"/>
           <p:cNvSpPr/>
           <p:nvPr/>
         </p:nvSpPr>
         <p:spPr>
           <a:xfrm>
-            <a:off x="777240" y="3264408"/>
-            <a:ext cx="3246120" cy="868680"/>
+            <a:off x="6217920" y="3337560"/>
+            <a:ext cx="5074920" cy="1143000"/>
           </a:xfrm>
           <a:prstGeom prst="rect">
             <a:avLst/>
@@ -4704,14 +5716,14 @@
       </p:sp>
       <p:sp>
         <p:nvSpPr>
-          <p:cNvPr id="16" name="TextBox 15"/>
+          <p:cNvPr id="15" name="TextBox 14"/>
           <p:cNvSpPr txBox="1"/>
           <p:nvPr/>
         </p:nvSpPr>
         <p:spPr>
           <a:xfrm>
-            <a:off x="978408" y="3383280"/>
-            <a:ext cx="2926080" cy="320040"/>
+            <a:off x="6492240" y="3502152"/>
+            <a:ext cx="4572000" cy="411480"/>
           </a:xfrm>
           <a:prstGeom prst="rect">
             <a:avLst/>
@@ -4733,27 +5745,27 @@
               </a:spcAft>
             </a:pPr>
             <a:r>
-              <a:rPr sz="1500" b="1">
-                <a:solidFill>
-                  <a:srgbClr val="101010"/>
+              <a:rPr sz="2200" b="1">
+                <a:solidFill>
+                  <a:srgbClr val="C04A12"/>
                 </a:solidFill>
                 <a:latin typeface="Calibri"/>
               </a:rPr>
-              <a:t>Missing data</a:t>
-            </a:r>
-          </a:p>
-        </p:txBody>
-      </p:sp>
-      <p:sp>
-        <p:nvSpPr>
-          <p:cNvPr id="17" name="TextBox 16"/>
+              <a:t>18 seconds</a:t>
+            </a:r>
+          </a:p>
+        </p:txBody>
+      </p:sp>
+      <p:sp>
+        <p:nvSpPr>
+          <p:cNvPr id="16" name="TextBox 15"/>
           <p:cNvSpPr txBox="1"/>
           <p:nvPr/>
         </p:nvSpPr>
         <p:spPr>
           <a:xfrm>
-            <a:off x="978408" y="3721608"/>
-            <a:ext cx="2926080" cy="320040"/>
+            <a:off x="6492240" y="3995928"/>
+            <a:ext cx="4572000" cy="411480"/>
           </a:xfrm>
           <a:prstGeom prst="rect">
             <a:avLst/>
@@ -4775,36 +5787,36 @@
               </a:spcAft>
             </a:pPr>
             <a:r>
-              <a:rPr sz="1200" b="0">
-                <a:solidFill>
-                  <a:srgbClr val="6B6A63"/>
+              <a:rPr sz="1400" b="0">
+                <a:solidFill>
+                  <a:srgbClr val="3D3C38"/>
                 </a:solidFill>
                 <a:latin typeface="Calibri"/>
               </a:rPr>
-              <a:t>excluded · worst case · capped</a:t>
-            </a:r>
-          </a:p>
-        </p:txBody>
-      </p:sp>
-      <p:sp>
-        <p:nvSpPr>
-          <p:cNvPr id="18" name="Rectangle 17"/>
+              <a:t>to run all 17,496 specifications on a laptop</a:t>
+            </a:r>
+          </a:p>
+        </p:txBody>
+      </p:sp>
+      <p:sp>
+        <p:nvSpPr>
+          <p:cNvPr id="17" name="Rectangle 16"/>
           <p:cNvSpPr/>
           <p:nvPr/>
         </p:nvSpPr>
         <p:spPr>
           <a:xfrm>
-            <a:off x="4389120" y="3264408"/>
-            <a:ext cx="3246120" cy="868680"/>
+            <a:off x="777240" y="4937760"/>
+            <a:ext cx="10607040" cy="1051560"/>
           </a:xfrm>
           <a:prstGeom prst="rect">
             <a:avLst/>
           </a:prstGeom>
-          <a:solidFill>
-            <a:srgbClr val="F2F1ED"/>
-          </a:solidFill>
-          <a:ln>
-            <a:noFill/>
+          <a:noFill/>
+          <a:ln w="31750">
+            <a:solidFill>
+              <a:srgbClr val="C04A12"/>
+            </a:solidFill>
           </a:ln>
           <a:effectLst/>
         </p:spPr>
@@ -4832,14 +5844,14 @@
       </p:sp>
       <p:sp>
         <p:nvSpPr>
-          <p:cNvPr id="19" name="TextBox 18"/>
+          <p:cNvPr id="18" name="TextBox 17"/>
           <p:cNvSpPr txBox="1"/>
           <p:nvPr/>
         </p:nvSpPr>
         <p:spPr>
           <a:xfrm>
-            <a:off x="4590288" y="3383280"/>
-            <a:ext cx="2926080" cy="320040"/>
+            <a:off x="1097280" y="5166360"/>
+            <a:ext cx="10058400" cy="640080"/>
           </a:xfrm>
           <a:prstGeom prst="rect">
             <a:avLst/>
@@ -4861,329 +5873,22 @@
               </a:spcAft>
             </a:pPr>
             <a:r>
-              <a:rPr sz="1500" b="1">
+              <a:rPr sz="2000" b="1">
                 <a:solidFill>
                   <a:srgbClr val="101010"/>
                 </a:solidFill>
                 <a:latin typeface="Calibri"/>
               </a:rPr>
-              <a:t>Aggregation</a:t>
-            </a:r>
-          </a:p>
-        </p:txBody>
-      </p:sp>
-      <p:sp>
-        <p:nvSpPr>
-          <p:cNvPr id="20" name="TextBox 19"/>
-          <p:cNvSpPr txBox="1"/>
-          <p:nvPr/>
-        </p:nvSpPr>
-        <p:spPr>
-          <a:xfrm>
-            <a:off x="4590288" y="3721608"/>
-            <a:ext cx="2926080" cy="320040"/>
-          </a:xfrm>
-          <a:prstGeom prst="rect">
-            <a:avLst/>
-          </a:prstGeom>
-          <a:noFill/>
-        </p:spPr>
-        <p:txBody>
-          <a:bodyPr wrap="square" anchor="t" lIns="0" rIns="0" tIns="0" bIns="0">
-            <a:spAutoFit/>
-          </a:bodyPr>
-          <a:lstStyle/>
-          <a:p>
-            <a:pPr algn="l">
-              <a:lnSpc>
-                <a:spcPct val="100000"/>
-              </a:lnSpc>
-              <a:spcAft>
-                <a:spcPts val="600"/>
-              </a:spcAft>
-            </a:pPr>
-            <a:r>
-              <a:rPr sz="1200" b="0">
-                <a:solidFill>
-                  <a:srgbClr val="6B6A63"/>
+              <a:t>If the framework survives here, it survives anywhere. </a:t>
+            </a:r>
+            <a:r>
+              <a:rPr sz="2000" b="0">
+                <a:solidFill>
+                  <a:srgbClr val="101010"/>
                 </a:solidFill>
                 <a:latin typeface="Calibri"/>
               </a:rPr>
-              <a:t>arithmetic · power · geometric</a:t>
-            </a:r>
-          </a:p>
-        </p:txBody>
-      </p:sp>
-      <p:sp>
-        <p:nvSpPr>
-          <p:cNvPr id="21" name="Rectangle 20"/>
-          <p:cNvSpPr/>
-          <p:nvPr/>
-        </p:nvSpPr>
-        <p:spPr>
-          <a:xfrm>
-            <a:off x="8001000" y="3264408"/>
-            <a:ext cx="3246120" cy="868680"/>
-          </a:xfrm>
-          <a:prstGeom prst="rect">
-            <a:avLst/>
-          </a:prstGeom>
-          <a:solidFill>
-            <a:srgbClr val="F2F1ED"/>
-          </a:solidFill>
-          <a:ln>
-            <a:noFill/>
-          </a:ln>
-          <a:effectLst/>
-        </p:spPr>
-        <p:style>
-          <a:lnRef idx="1">
-            <a:schemeClr val="accent1"/>
-          </a:lnRef>
-          <a:fillRef idx="3">
-            <a:schemeClr val="accent1"/>
-          </a:fillRef>
-          <a:effectRef idx="2">
-            <a:schemeClr val="accent1"/>
-          </a:effectRef>
-          <a:fontRef idx="minor">
-            <a:schemeClr val="lt1"/>
-          </a:fontRef>
-        </p:style>
-        <p:txBody>
-          <a:bodyPr rtlCol="0" anchor="ctr"/>
-          <a:lstStyle/>
-          <a:p>
-            <a:pPr algn="ctr"/>
-          </a:p>
-        </p:txBody>
-      </p:sp>
-      <p:sp>
-        <p:nvSpPr>
-          <p:cNvPr id="22" name="TextBox 21"/>
-          <p:cNvSpPr txBox="1"/>
-          <p:nvPr/>
-        </p:nvSpPr>
-        <p:spPr>
-          <a:xfrm>
-            <a:off x="8202168" y="3383280"/>
-            <a:ext cx="2926080" cy="320040"/>
-          </a:xfrm>
-          <a:prstGeom prst="rect">
-            <a:avLst/>
-          </a:prstGeom>
-          <a:noFill/>
-        </p:spPr>
-        <p:txBody>
-          <a:bodyPr wrap="square" anchor="t" lIns="0" rIns="0" tIns="0" bIns="0">
-            <a:spAutoFit/>
-          </a:bodyPr>
-          <a:lstStyle/>
-          <a:p>
-            <a:pPr algn="l">
-              <a:lnSpc>
-                <a:spcPct val="100000"/>
-              </a:lnSpc>
-              <a:spcAft>
-                <a:spcPts val="600"/>
-              </a:spcAft>
-            </a:pPr>
-            <a:r>
-              <a:rPr sz="1500" b="1">
-                <a:solidFill>
-                  <a:srgbClr val="101010"/>
-                </a:solidFill>
-                <a:latin typeface="Calibri"/>
-              </a:rPr>
-              <a:t>Pillar weights</a:t>
-            </a:r>
-          </a:p>
-        </p:txBody>
-      </p:sp>
-      <p:sp>
-        <p:nvSpPr>
-          <p:cNvPr id="23" name="TextBox 22"/>
-          <p:cNvSpPr txBox="1"/>
-          <p:nvPr/>
-        </p:nvSpPr>
-        <p:spPr>
-          <a:xfrm>
-            <a:off x="8202168" y="3721608"/>
-            <a:ext cx="2926080" cy="320040"/>
-          </a:xfrm>
-          <a:prstGeom prst="rect">
-            <a:avLst/>
-          </a:prstGeom>
-          <a:noFill/>
-        </p:spPr>
-        <p:txBody>
-          <a:bodyPr wrap="square" anchor="t" lIns="0" rIns="0" tIns="0" bIns="0">
-            <a:spAutoFit/>
-          </a:bodyPr>
-          <a:lstStyle/>
-          <a:p>
-            <a:pPr algn="l">
-              <a:lnSpc>
-                <a:spcPct val="100000"/>
-              </a:lnSpc>
-              <a:spcAft>
-                <a:spcPts val="600"/>
-              </a:spcAft>
-            </a:pPr>
-            <a:r>
-              <a:rPr sz="1200" b="0">
-                <a:solidFill>
-                  <a:srgbClr val="6B6A63"/>
-                </a:solidFill>
-                <a:latin typeface="Calibri"/>
-              </a:rPr>
-              <a:t>user slider, five presets</a:t>
-            </a:r>
-          </a:p>
-        </p:txBody>
-      </p:sp>
-      <p:sp>
-        <p:nvSpPr>
-          <p:cNvPr id="24" name="Rectangle 23"/>
-          <p:cNvSpPr/>
-          <p:nvPr/>
-        </p:nvSpPr>
-        <p:spPr>
-          <a:xfrm>
-            <a:off x="777240" y="4480560"/>
-            <a:ext cx="10607040" cy="914400"/>
-          </a:xfrm>
-          <a:prstGeom prst="rect">
-            <a:avLst/>
-          </a:prstGeom>
-          <a:noFill/>
-          <a:ln w="31750">
-            <a:solidFill>
-              <a:srgbClr val="C04A12"/>
-            </a:solidFill>
-          </a:ln>
-          <a:effectLst/>
-        </p:spPr>
-        <p:style>
-          <a:lnRef idx="1">
-            <a:schemeClr val="accent1"/>
-          </a:lnRef>
-          <a:fillRef idx="3">
-            <a:schemeClr val="accent1"/>
-          </a:fillRef>
-          <a:effectRef idx="2">
-            <a:schemeClr val="accent1"/>
-          </a:effectRef>
-          <a:fontRef idx="minor">
-            <a:schemeClr val="lt1"/>
-          </a:fontRef>
-        </p:style>
-        <p:txBody>
-          <a:bodyPr rtlCol="0" anchor="ctr"/>
-          <a:lstStyle/>
-          <a:p>
-            <a:pPr algn="ctr"/>
-          </a:p>
-        </p:txBody>
-      </p:sp>
-      <p:sp>
-        <p:nvSpPr>
-          <p:cNvPr id="25" name="TextBox 24"/>
-          <p:cNvSpPr txBox="1"/>
-          <p:nvPr/>
-        </p:nvSpPr>
-        <p:spPr>
-          <a:xfrm>
-            <a:off x="1051560" y="4663440"/>
-            <a:ext cx="10058400" cy="640080"/>
-          </a:xfrm>
-          <a:prstGeom prst="rect">
-            <a:avLst/>
-          </a:prstGeom>
-          <a:noFill/>
-        </p:spPr>
-        <p:txBody>
-          <a:bodyPr wrap="square" anchor="t" lIns="0" rIns="0" tIns="0" bIns="0">
-            <a:spAutoFit/>
-          </a:bodyPr>
-          <a:lstStyle/>
-          <a:p>
-            <a:pPr algn="l">
-              <a:lnSpc>
-                <a:spcPct val="100000"/>
-              </a:lnSpc>
-              <a:spcAft>
-                <a:spcPts val="600"/>
-              </a:spcAft>
-            </a:pPr>
-            <a:r>
-              <a:rPr sz="1900" b="0">
-                <a:solidFill>
-                  <a:srgbClr val="101010"/>
-                </a:solidFill>
-                <a:latin typeface="Calibri"/>
-              </a:rPr>
-              <a:t>Then the correction that mattered: </a:t>
-            </a:r>
-            <a:r>
-              <a:rPr sz="1900" b="1">
-                <a:solidFill>
-                  <a:srgbClr val="101010"/>
-                </a:solidFill>
-                <a:latin typeface="Calibri"/>
-              </a:rPr>
-              <a:t>“best today” and “improving fastest” are different questions.</a:t>
-            </a:r>
-            <a:r>
-              <a:rPr sz="1900" b="0">
-                <a:solidFill>
-                  <a:srgbClr val="101010"/>
-                </a:solidFill>
-                <a:latin typeface="Calibri"/>
-              </a:rPr>
-              <a:t> We score them separately.</a:t>
-            </a:r>
-          </a:p>
-        </p:txBody>
-      </p:sp>
-      <p:sp>
-        <p:nvSpPr>
-          <p:cNvPr id="26" name="TextBox 25"/>
-          <p:cNvSpPr txBox="1"/>
-          <p:nvPr/>
-        </p:nvSpPr>
-        <p:spPr>
-          <a:xfrm>
-            <a:off x="777240" y="6263640"/>
-            <a:ext cx="10607040" cy="365760"/>
-          </a:xfrm>
-          <a:prstGeom prst="rect">
-            <a:avLst/>
-          </a:prstGeom>
-          <a:noFill/>
-        </p:spPr>
-        <p:txBody>
-          <a:bodyPr wrap="square" anchor="t" lIns="0" rIns="0" tIns="0" bIns="0">
-            <a:spAutoFit/>
-          </a:bodyPr>
-          <a:lstStyle/>
-          <a:p>
-            <a:pPr algn="l">
-              <a:lnSpc>
-                <a:spcPct val="100000"/>
-              </a:lnSpc>
-              <a:spcAft>
-                <a:spcPts val="600"/>
-              </a:spcAft>
-            </a:pPr>
-            <a:r>
-              <a:rPr sz="1100" b="0">
-                <a:solidFill>
-                  <a:srgbClr val="6B6A63"/>
-                </a:solidFill>
-                <a:latin typeface="Calibri"/>
-              </a:rPr>
-              <a:t>Specification curve analysis, Simonsohn, Simmons &amp; Nelson, Nature Human Behaviour 2020.</a:t>
+              <a:t>Now watch what happens when I change one convention.</a:t>
             </a:r>
           </a:p>
         </p:txBody>
@@ -5221,7 +5926,7 @@
             <a:avLst/>
           </a:prstGeom>
           <a:solidFill>
-            <a:srgbClr val="FCFCFB"/>
+            <a:srgbClr val="101010"/>
           </a:solidFill>
           <a:ln>
             <a:noFill/>
@@ -5258,8 +5963,8 @@
         </p:nvSpPr>
         <p:spPr>
           <a:xfrm>
-            <a:off x="777240" y="457200"/>
-            <a:ext cx="10058400" cy="365760"/>
+            <a:off x="777240" y="2011680"/>
+            <a:ext cx="10607040" cy="640080"/>
           </a:xfrm>
           <a:prstGeom prst="rect">
             <a:avLst/>
@@ -5281,13 +5986,13 @@
               </a:spcAft>
             </a:pPr>
             <a:r>
-              <a:rPr sz="1300" b="1">
+              <a:rPr sz="2000" b="1">
                 <a:solidFill>
                   <a:srgbClr val="C04A12"/>
                 </a:solidFill>
                 <a:latin typeface="Calibri"/>
               </a:rPr>
-              <a:t>THE RESULT</a:t>
+              <a:t>LIVE</a:t>
             </a:r>
           </a:p>
         </p:txBody>
@@ -5300,8 +6005,8 @@
         </p:nvSpPr>
         <p:spPr>
           <a:xfrm>
-            <a:off x="777240" y="868680"/>
-            <a:ext cx="5669280" cy="2377440"/>
+            <a:off x="777240" y="2514600"/>
+            <a:ext cx="10607040" cy="1645920"/>
           </a:xfrm>
           <a:prstGeom prst="rect">
             <a:avLst/>
@@ -5319,17 +6024,17 @@
                 <a:spcPct val="100000"/>
               </a:lnSpc>
               <a:spcAft>
-                <a:spcPts val="300"/>
+                <a:spcPts val="200"/>
               </a:spcAft>
             </a:pPr>
             <a:r>
-              <a:rPr sz="9200" b="1">
-                <a:solidFill>
-                  <a:srgbClr val="C04A12"/>
+              <a:rPr sz="5600" b="1">
+                <a:solidFill>
+                  <a:srgbClr val="FFFFFF"/>
                 </a:solidFill>
                 <a:latin typeface="Calibri"/>
               </a:rPr>
-              <a:t>33</a:t>
+              <a:t>Move one switch.</a:t>
             </a:r>
           </a:p>
           <a:p>
@@ -5338,55 +6043,17 @@
                 <a:spcPct val="100000"/>
               </a:lnSpc>
               <a:spcAft>
-                <a:spcPts val="300"/>
+                <a:spcPts val="200"/>
               </a:spcAft>
             </a:pPr>
             <a:r>
-              <a:rPr sz="2200" b="1">
-                <a:solidFill>
-                  <a:srgbClr val="101010"/>
+              <a:rPr sz="5600" b="1">
+                <a:solidFill>
+                  <a:srgbClr val="FFFFFF"/>
                 </a:solidFill>
                 <a:latin typeface="Calibri"/>
               </a:rPr>
-              <a:t>of 153 pairwise comparisons survive</a:t>
-            </a:r>
-          </a:p>
-          <a:p>
-            <a:pPr algn="l">
-              <a:lnSpc>
-                <a:spcPct val="100000"/>
-              </a:lnSpc>
-              <a:spcAft>
-                <a:spcPts val="300"/>
-              </a:spcAft>
-            </a:pPr>
-            <a:r>
-              <a:rPr sz="2200" b="1">
-                <a:solidFill>
-                  <a:srgbClr val="101010"/>
-                </a:solidFill>
-                <a:latin typeface="Calibri"/>
-              </a:rPr>
-              <a:t>every defensible method.</a:t>
-            </a:r>
-          </a:p>
-          <a:p>
-            <a:pPr algn="l">
-              <a:lnSpc>
-                <a:spcPct val="100000"/>
-              </a:lnSpc>
-              <a:spcAft>
-                <a:spcPts val="300"/>
-              </a:spcAft>
-            </a:pPr>
-            <a:r>
-              <a:rPr sz="1700" b="0">
-                <a:solidFill>
-                  <a:srgbClr val="3D3C38"/>
-                </a:solidFill>
-                <a:latin typeface="Calibri"/>
-              </a:rPr>
-              <a:t>A published league table asserts all 153.</a:t>
+              <a:t>Watch the ranking change.</a:t>
             </a:r>
           </a:p>
         </p:txBody>
@@ -5399,111 +6066,8 @@
         </p:nvSpPr>
         <p:spPr>
           <a:xfrm>
-            <a:off x="777240" y="3566160"/>
-            <a:ext cx="5669280" cy="2194560"/>
-          </a:xfrm>
-          <a:prstGeom prst="rect">
-            <a:avLst/>
-          </a:prstGeom>
-          <a:noFill/>
-        </p:spPr>
-        <p:txBody>
-          <a:bodyPr wrap="square" anchor="t" lIns="0" rIns="0" tIns="0" bIns="0">
-            <a:spAutoFit/>
-          </a:bodyPr>
-          <a:lstStyle/>
-          <a:p>
-            <a:pPr algn="l">
-              <a:lnSpc>
-                <a:spcPct val="120000"/>
-              </a:lnSpc>
-              <a:spcAft>
-                <a:spcPts val="1000"/>
-              </a:spcAft>
-            </a:pPr>
-            <a:r>
-              <a:rPr sz="1900" b="0">
-                <a:solidFill>
-                  <a:srgbClr val="3D3C38"/>
-                </a:solidFill>
-                <a:latin typeface="Calibri"/>
-              </a:rPr>
-              <a:t>The median company still moves </a:t>
-            </a:r>
-            <a:r>
-              <a:rPr sz="1900" b="1">
-                <a:solidFill>
-                  <a:srgbClr val="C04A12"/>
-                </a:solidFill>
-                <a:latin typeface="Calibri"/>
-              </a:rPr>
-              <a:t>3 places of 18</a:t>
-            </a:r>
-            <a:r>
-              <a:rPr sz="1900" b="0">
-                <a:solidFill>
-                  <a:srgbClr val="3D3C38"/>
-                </a:solidFill>
-                <a:latin typeface="Calibri"/>
-              </a:rPr>
-              <a:t> on method choice alone, after we hold the question and the peer group fixed.</a:t>
-            </a:r>
-          </a:p>
-          <a:p>
-            <a:pPr algn="l">
-              <a:lnSpc>
-                <a:spcPct val="120000"/>
-              </a:lnSpc>
-              <a:spcAft>
-                <a:spcPts val="1000"/>
-              </a:spcAft>
-            </a:pPr>
-            <a:r>
-              <a:rPr sz="1700" b="0">
-                <a:solidFill>
-                  <a:srgbClr val="6B6A63"/>
-                </a:solidFill>
-                <a:latin typeface="Calibri"/>
-              </a:rPr>
-              <a:t>Two axes decide it: what you ask, and who you ask it against. Neither is a weight.</a:t>
-            </a:r>
-          </a:p>
-        </p:txBody>
-      </p:sp>
-      <p:pic>
-        <p:nvPicPr>
-          <p:cNvPr id="6" name="Picture 5" descr="f3_variance.png"/>
-          <p:cNvPicPr>
-            <a:picLocks noChangeAspect="1"/>
-          </p:cNvPicPr>
-          <p:nvPr/>
-        </p:nvPicPr>
-        <p:blipFill>
-          <a:blip r:embed="rId2"/>
-          <a:stretch>
-            <a:fillRect/>
-          </a:stretch>
-        </p:blipFill>
-        <p:spPr>
-          <a:xfrm>
-            <a:off x="6720840" y="1051560"/>
-            <a:ext cx="4846320" cy="1817370"/>
-          </a:xfrm>
-          <a:prstGeom prst="rect">
-            <a:avLst/>
-          </a:prstGeom>
-        </p:spPr>
-      </p:pic>
-      <p:sp>
-        <p:nvSpPr>
-          <p:cNvPr id="7" name="TextBox 6"/>
-          <p:cNvSpPr txBox="1"/>
-          <p:nvPr/>
-        </p:nvSpPr>
-        <p:spPr>
-          <a:xfrm>
-            <a:off x="6720840" y="4892040"/>
-            <a:ext cx="4846320" cy="365760"/>
+            <a:off x="777240" y="4572000"/>
+            <a:ext cx="10607040" cy="731520"/>
           </a:xfrm>
           <a:prstGeom prst="rect">
             <a:avLst/>
@@ -5525,55 +6089,13 @@
               </a:spcAft>
             </a:pPr>
             <a:r>
-              <a:rPr sz="1200" b="0">
-                <a:solidFill>
-                  <a:srgbClr val="6B6A63"/>
+              <a:rPr sz="2200" b="0">
+                <a:solidFill>
+                  <a:srgbClr val="B8B7B1"/>
                 </a:solidFill>
                 <a:latin typeface="Calibri"/>
               </a:rPr>
-              <a:t>Share of a company's rank variance, by choice</a:t>
-            </a:r>
-          </a:p>
-        </p:txBody>
-      </p:sp>
-      <p:sp>
-        <p:nvSpPr>
-          <p:cNvPr id="8" name="TextBox 7"/>
-          <p:cNvSpPr txBox="1"/>
-          <p:nvPr/>
-        </p:nvSpPr>
-        <p:spPr>
-          <a:xfrm>
-            <a:off x="777240" y="6263640"/>
-            <a:ext cx="10607040" cy="365760"/>
-          </a:xfrm>
-          <a:prstGeom prst="rect">
-            <a:avLst/>
-          </a:prstGeom>
-          <a:noFill/>
-        </p:spPr>
-        <p:txBody>
-          <a:bodyPr wrap="square" anchor="t" lIns="0" rIns="0" tIns="0" bIns="0">
-            <a:spAutoFit/>
-          </a:bodyPr>
-          <a:lstStyle/>
-          <a:p>
-            <a:pPr algn="l">
-              <a:lnSpc>
-                <a:spcPct val="100000"/>
-              </a:lnSpc>
-              <a:spcAft>
-                <a:spcPts val="600"/>
-              </a:spcAft>
-            </a:pPr>
-            <a:r>
-              <a:rPr sz="1100" b="0">
-                <a:solidFill>
-                  <a:srgbClr val="6B6A63"/>
-                </a:solidFill>
-                <a:latin typeface="Calibri"/>
-              </a:rPr>
-              <a:t>Full grid runs in 18 seconds. Every figure regenerates from the committed pipeline.</a:t>
+              <a:t>17,496 specifications, recomputed in the browser, in real time.</a:t>
             </a:r>
           </a:p>
         </p:txBody>
@@ -5611,7 +6133,7 @@
             <a:avLst/>
           </a:prstGeom>
           <a:solidFill>
-            <a:srgbClr val="101010"/>
+            <a:srgbClr val="FCFCFB"/>
           </a:solidFill>
           <a:ln>
             <a:noFill/>
@@ -5648,8 +6170,8 @@
         </p:nvSpPr>
         <p:spPr>
           <a:xfrm>
-            <a:off x="777240" y="2194560"/>
-            <a:ext cx="10607040" cy="1097280"/>
+            <a:off x="777240" y="411480"/>
+            <a:ext cx="10607040" cy="365760"/>
           </a:xfrm>
           <a:prstGeom prst="rect">
             <a:avLst/>
@@ -5671,13 +6193,13 @@
               </a:spcAft>
             </a:pPr>
             <a:r>
-              <a:rPr sz="2200" b="1">
+              <a:rPr sz="1300" b="1">
                 <a:solidFill>
                   <a:srgbClr val="C04A12"/>
                 </a:solidFill>
                 <a:latin typeface="Calibri"/>
               </a:rPr>
-              <a:t>LIVE</a:t>
+              <a:t>BONUS  ·  ONE BILLION DOLLARS UNDER A NET-ZERO COMMITMENT</a:t>
             </a:r>
           </a:p>
         </p:txBody>
@@ -5690,8 +6212,8 @@
         </p:nvSpPr>
         <p:spPr>
           <a:xfrm>
-            <a:off x="777240" y="2651760"/>
-            <a:ext cx="10607040" cy="1463040"/>
+            <a:off x="777240" y="868680"/>
+            <a:ext cx="10607040" cy="685800"/>
           </a:xfrm>
           <a:prstGeom prst="rect">
             <a:avLst/>
@@ -5713,93 +6235,66 @@
               </a:spcAft>
             </a:pPr>
             <a:r>
-              <a:rPr sz="5200" b="1">
-                <a:solidFill>
-                  <a:srgbClr val="FFFFFF"/>
+              <a:rPr sz="3200" b="0">
+                <a:solidFill>
+                  <a:srgbClr val="101010"/>
                 </a:solidFill>
                 <a:latin typeface="Calibri"/>
               </a:rPr>
-              <a:t>Move a slider. Watch the ranking change.</a:t>
-            </a:r>
-          </a:p>
-        </p:txBody>
-      </p:sp>
-      <p:sp>
-        <p:nvSpPr>
-          <p:cNvPr id="5" name="TextBox 4"/>
-          <p:cNvSpPr txBox="1"/>
+              <a:t>Buy the companies the market </a:t>
+            </a:r>
+            <a:r>
+              <a:rPr sz="3200" b="1">
+                <a:solidFill>
+                  <a:srgbClr val="C04A12"/>
+                </a:solidFill>
+                <a:latin typeface="Calibri"/>
+              </a:rPr>
+              <a:t>cannot yet classify.</a:t>
+            </a:r>
+          </a:p>
+        </p:txBody>
+      </p:sp>
+      <p:pic>
+        <p:nvPicPr>
+          <p:cNvPr id="5" name="Picture 4" descr="f4_eligibility.png"/>
+          <p:cNvPicPr>
+            <a:picLocks noChangeAspect="1"/>
+          </p:cNvPicPr>
           <p:nvPr/>
-        </p:nvSpPr>
-        <p:spPr>
-          <a:xfrm>
-            <a:off x="777240" y="4114800"/>
-            <a:ext cx="10607040" cy="914400"/>
+        </p:nvPicPr>
+        <p:blipFill>
+          <a:blip r:embed="rId2"/>
+          <a:stretch>
+            <a:fillRect/>
+          </a:stretch>
+        </p:blipFill>
+        <p:spPr>
+          <a:xfrm>
+            <a:off x="777240" y="1691640"/>
+            <a:ext cx="5349240" cy="2377440"/>
           </a:xfrm>
           <a:prstGeom prst="rect">
             <a:avLst/>
           </a:prstGeom>
-          <a:noFill/>
-        </p:spPr>
-        <p:txBody>
-          <a:bodyPr wrap="square" anchor="t" lIns="0" rIns="0" tIns="0" bIns="0">
-            <a:spAutoFit/>
-          </a:bodyPr>
-          <a:lstStyle/>
-          <a:p>
-            <a:pPr algn="l">
-              <a:lnSpc>
-                <a:spcPct val="100000"/>
-              </a:lnSpc>
-              <a:spcAft>
-                <a:spcPts val="600"/>
-              </a:spcAft>
-            </a:pPr>
-            <a:r>
-              <a:rPr sz="2200" b="0">
-                <a:solidFill>
-                  <a:srgbClr val="B8B7B1"/>
-                </a:solidFill>
-                <a:latin typeface="Calibri"/>
-              </a:rPr>
-              <a:t>17,496 specifications, recomputed in the browser, in real time.</a:t>
-            </a:r>
-          </a:p>
-        </p:txBody>
-      </p:sp>
-    </p:spTree>
-  </p:cSld>
-  <p:clrMapOvr>
-    <a:masterClrMapping/>
-  </p:clrMapOvr>
-</p:sld>
-</file>
-
-<file path=ppt/slides/slide6.xml><?xml version="1.0" encoding="utf-8"?>
-<p:sld xmlns:a="http://schemas.openxmlformats.org/drawingml/2006/main" xmlns:p="http://schemas.openxmlformats.org/presentationml/2006/main" xmlns:r="http://schemas.openxmlformats.org/officeDocument/2006/relationships">
-  <p:cSld>
-    <p:spTree>
-      <p:nvGrpSpPr>
-        <p:cNvPr id="1" name=""/>
-        <p:cNvGrpSpPr/>
-        <p:nvPr/>
-      </p:nvGrpSpPr>
-      <p:grpSpPr/>
-      <p:sp>
-        <p:nvSpPr>
-          <p:cNvPr id="2" name="Rectangle 1"/>
+        </p:spPr>
+      </p:pic>
+      <p:sp>
+        <p:nvSpPr>
+          <p:cNvPr id="6" name="Rectangle 5"/>
           <p:cNvSpPr/>
           <p:nvPr/>
         </p:nvSpPr>
         <p:spPr>
           <a:xfrm>
-            <a:off x="0" y="0"/>
-            <a:ext cx="12191695" cy="6858000"/>
+            <a:off x="6537960" y="1691640"/>
+            <a:ext cx="4846320" cy="3429000"/>
           </a:xfrm>
           <a:prstGeom prst="rect">
             <a:avLst/>
           </a:prstGeom>
           <a:solidFill>
-            <a:srgbClr val="FCFCFB"/>
+            <a:srgbClr val="F2F1ED"/>
           </a:solidFill>
           <a:ln>
             <a:noFill/>
@@ -5830,14 +6325,14 @@
       </p:sp>
       <p:sp>
         <p:nvSpPr>
-          <p:cNvPr id="3" name="TextBox 2"/>
+          <p:cNvPr id="7" name="TextBox 6"/>
           <p:cNvSpPr txBox="1"/>
           <p:nvPr/>
         </p:nvSpPr>
         <p:spPr>
           <a:xfrm>
-            <a:off x="777240" y="457200"/>
-            <a:ext cx="10058400" cy="365760"/>
+            <a:off x="6858000" y="1920240"/>
+            <a:ext cx="4297680" cy="3017520"/>
           </a:xfrm>
           <a:prstGeom prst="rect">
             <a:avLst/>
@@ -5852,157 +6347,133 @@
           <a:p>
             <a:pPr algn="l">
               <a:lnSpc>
-                <a:spcPct val="100000"/>
+                <a:spcPct val="112000"/>
               </a:lnSpc>
               <a:spcAft>
-                <a:spcPts val="600"/>
+                <a:spcPts val="1000"/>
               </a:spcAft>
             </a:pPr>
             <a:r>
-              <a:rPr sz="1300" b="1">
+              <a:rPr sz="4000" b="1">
                 <a:solidFill>
                   <a:srgbClr val="C04A12"/>
                 </a:solidFill>
                 <a:latin typeface="Calibri"/>
               </a:rPr>
-              <a:t>BONUS · $1BN UNDER A NET-ZERO COMMITMENT</a:t>
-            </a:r>
-          </a:p>
-        </p:txBody>
-      </p:sp>
-      <p:sp>
-        <p:nvSpPr>
-          <p:cNvPr id="4" name="TextBox 3"/>
-          <p:cNvSpPr txBox="1"/>
-          <p:nvPr/>
-        </p:nvSpPr>
-        <p:spPr>
-          <a:xfrm>
-            <a:off x="777240" y="868680"/>
-            <a:ext cx="10607040" cy="731520"/>
-          </a:xfrm>
-          <a:prstGeom prst="rect">
-            <a:avLst/>
-          </a:prstGeom>
-          <a:noFill/>
-        </p:spPr>
-        <p:txBody>
-          <a:bodyPr wrap="square" anchor="t" lIns="0" rIns="0" tIns="0" bIns="0">
-            <a:spAutoFit/>
-          </a:bodyPr>
-          <a:lstStyle/>
+              <a:t>15 of 18</a:t>
+            </a:r>
+          </a:p>
           <a:p>
             <a:pPr algn="l">
               <a:lnSpc>
-                <a:spcPct val="100000"/>
+                <a:spcPct val="112000"/>
               </a:lnSpc>
               <a:spcAft>
-                <a:spcPts val="600"/>
+                <a:spcPts val="1000"/>
               </a:spcAft>
             </a:pPr>
             <a:r>
-              <a:rPr sz="3100" b="0">
-                <a:solidFill>
-                  <a:srgbClr val="101010"/>
+              <a:rPr sz="1500" b="0">
+                <a:solidFill>
+                  <a:srgbClr val="3D3C38"/>
                 </a:solidFill>
                 <a:latin typeface="Calibri"/>
               </a:rPr>
-              <a:t>Buy the companies the market </a:t>
-            </a:r>
-            <a:r>
-              <a:rPr sz="3100" b="1">
-                <a:solidFill>
-                  <a:srgbClr val="C04A12"/>
+              <a:t>companies are between 20% and 80% likely to pass a sustainable-fund screen.</a:t>
+            </a:r>
+          </a:p>
+          <a:p>
+            <a:pPr algn="l">
+              <a:lnSpc>
+                <a:spcPct val="112000"/>
+              </a:lnSpc>
+              <a:spcAft>
+                <a:spcPts val="1000"/>
+              </a:spcAft>
+            </a:pPr>
+            <a:r>
+              <a:rPr sz="1500" b="0">
+                <a:solidFill>
+                  <a:srgbClr val="3D3C38"/>
                 </a:solidFill>
                 <a:latin typeface="Calibri"/>
               </a:rPr>
-              <a:t>cannot yet classify.</a:t>
-            </a:r>
-          </a:p>
-        </p:txBody>
-      </p:sp>
-      <p:sp>
-        <p:nvSpPr>
-          <p:cNvPr id="5" name="TextBox 4"/>
-          <p:cNvSpPr txBox="1"/>
-          <p:nvPr/>
-        </p:nvSpPr>
-        <p:spPr>
-          <a:xfrm>
-            <a:off x="777240" y="1554480"/>
-            <a:ext cx="10607040" cy="548640"/>
-          </a:xfrm>
-          <a:prstGeom prst="rect">
-            <a:avLst/>
-          </a:prstGeom>
-          <a:noFill/>
-        </p:spPr>
-        <p:txBody>
-          <a:bodyPr wrap="square" anchor="t" lIns="0" rIns="0" tIns="0" bIns="0">
-            <a:spAutoFit/>
-          </a:bodyPr>
-          <a:lstStyle/>
+              <a:t>There is no threshold to cross. So the trade is not crossing a line, it is the gap between where a company </a:t>
+            </a:r>
+            <a:r>
+              <a:rPr sz="1500" b="1">
+                <a:solidFill>
+                  <a:srgbClr val="101010"/>
+                </a:solidFill>
+                <a:latin typeface="Calibri"/>
+              </a:rPr>
+              <a:t>stands</a:t>
+            </a:r>
+            <a:r>
+              <a:rPr sz="1500" b="0">
+                <a:solidFill>
+                  <a:srgbClr val="3D3C38"/>
+                </a:solidFill>
+                <a:latin typeface="Calibri"/>
+              </a:rPr>
+              <a:t> and where it is </a:t>
+            </a:r>
+            <a:r>
+              <a:rPr sz="1500" b="1">
+                <a:solidFill>
+                  <a:srgbClr val="101010"/>
+                </a:solidFill>
+                <a:latin typeface="Calibri"/>
+              </a:rPr>
+              <a:t>heading</a:t>
+            </a:r>
+            <a:r>
+              <a:rPr sz="1500" b="0">
+                <a:solidFill>
+                  <a:srgbClr val="3D3C38"/>
+                </a:solidFill>
+                <a:latin typeface="Calibri"/>
+              </a:rPr>
+              <a:t>.</a:t>
+            </a:r>
+          </a:p>
           <a:p>
             <a:pPr algn="l">
               <a:lnSpc>
-                <a:spcPct val="100000"/>
+                <a:spcPct val="112000"/>
               </a:lnSpc>
               <a:spcAft>
-                <a:spcPts val="600"/>
+                <a:spcPts val="1000"/>
               </a:spcAft>
             </a:pPr>
             <a:r>
-              <a:rPr sz="1800" b="0">
-                <a:solidFill>
-                  <a:srgbClr val="3D3C38"/>
+              <a:rPr sz="1600" b="1">
+                <a:solidFill>
+                  <a:srgbClr val="C04A12"/>
                 </a:solidFill>
                 <a:latin typeface="Calibri"/>
               </a:rPr>
-              <a:t>We tested the “ESG threshold unlocks capital” thesis on our own data. There is no threshold.</a:t>
-            </a:r>
-          </a:p>
-        </p:txBody>
-      </p:sp>
-      <p:pic>
-        <p:nvPicPr>
-          <p:cNvPr id="6" name="Picture 5" descr="f4_eligibility.png"/>
-          <p:cNvPicPr>
-            <a:picLocks noChangeAspect="1"/>
-          </p:cNvPicPr>
-          <p:nvPr/>
-        </p:nvPicPr>
-        <p:blipFill>
-          <a:blip r:embed="rId2"/>
-          <a:stretch>
-            <a:fillRect/>
-          </a:stretch>
-        </p:blipFill>
-        <p:spPr>
-          <a:xfrm>
-            <a:off x="777240" y="2103120"/>
-            <a:ext cx="5394960" cy="2397760"/>
-          </a:xfrm>
-          <a:prstGeom prst="rect">
-            <a:avLst/>
-          </a:prstGeom>
-        </p:spPr>
-      </p:pic>
-      <p:sp>
-        <p:nvSpPr>
-          <p:cNvPr id="7" name="Rectangle 6"/>
+              <a:t>MPC +0.61    OXY +0.41    PSX +0.28</a:t>
+            </a:r>
+          </a:p>
+        </p:txBody>
+      </p:sp>
+      <p:sp>
+        <p:nvSpPr>
+          <p:cNvPr id="8" name="Rectangle 7"/>
           <p:cNvSpPr/>
           <p:nvPr/>
         </p:nvSpPr>
         <p:spPr>
           <a:xfrm>
-            <a:off x="6537960" y="2103120"/>
-            <a:ext cx="4846320" cy="3200400"/>
+            <a:off x="777240" y="5440680"/>
+            <a:ext cx="10607040" cy="38100"/>
           </a:xfrm>
           <a:prstGeom prst="rect">
             <a:avLst/>
           </a:prstGeom>
           <a:solidFill>
-            <a:srgbClr val="F2F1ED"/>
+            <a:srgbClr val="101010"/>
           </a:solidFill>
           <a:ln>
             <a:noFill/>
@@ -6033,212 +6504,14 @@
       </p:sp>
       <p:sp>
         <p:nvSpPr>
-          <p:cNvPr id="8" name="TextBox 7"/>
+          <p:cNvPr id="9" name="TextBox 8"/>
           <p:cNvSpPr txBox="1"/>
           <p:nvPr/>
         </p:nvSpPr>
         <p:spPr>
           <a:xfrm>
-            <a:off x="6812280" y="2331720"/>
-            <a:ext cx="4389120" cy="2834640"/>
-          </a:xfrm>
-          <a:prstGeom prst="rect">
-            <a:avLst/>
-          </a:prstGeom>
-          <a:noFill/>
-        </p:spPr>
-        <p:txBody>
-          <a:bodyPr wrap="square" anchor="t" lIns="0" rIns="0" tIns="0" bIns="0">
-            <a:spAutoFit/>
-          </a:bodyPr>
-          <a:lstStyle/>
-          <a:p>
-            <a:pPr algn="l">
-              <a:lnSpc>
-                <a:spcPct val="112000"/>
-              </a:lnSpc>
-              <a:spcAft>
-                <a:spcPts val="900"/>
-              </a:spcAft>
-            </a:pPr>
-            <a:r>
-              <a:rPr sz="3400" b="1">
-                <a:solidFill>
-                  <a:srgbClr val="C04A12"/>
-                </a:solidFill>
-                <a:latin typeface="Calibri"/>
-              </a:rPr>
-              <a:t>15 of 18</a:t>
-            </a:r>
-          </a:p>
-          <a:p>
-            <a:pPr algn="l">
-              <a:lnSpc>
-                <a:spcPct val="112000"/>
-              </a:lnSpc>
-              <a:spcAft>
-                <a:spcPts val="900"/>
-              </a:spcAft>
-            </a:pPr>
-            <a:r>
-              <a:rPr sz="1500" b="0">
-                <a:solidFill>
-                  <a:srgbClr val="3D3C38"/>
-                </a:solidFill>
-                <a:latin typeface="Calibri"/>
-              </a:rPr>
-              <a:t>companies sit between 20% and 80% likely to pass a top-half screen.</a:t>
-            </a:r>
-          </a:p>
-          <a:p>
-            <a:pPr algn="l">
-              <a:lnSpc>
-                <a:spcPct val="112000"/>
-              </a:lnSpc>
-              <a:spcAft>
-                <a:spcPts val="900"/>
-              </a:spcAft>
-            </a:pPr>
-            <a:r>
-              <a:rPr sz="1500" b="0">
-                <a:solidFill>
-                  <a:srgbClr val="3D3C38"/>
-                </a:solidFill>
-                <a:latin typeface="Calibri"/>
-              </a:rPr>
-              <a:t>So the tradeable number is not crossing a line. It is the gap between where a company </a:t>
-            </a:r>
-            <a:r>
-              <a:rPr sz="1500" b="1">
-                <a:solidFill>
-                  <a:srgbClr val="101010"/>
-                </a:solidFill>
-                <a:latin typeface="Calibri"/>
-              </a:rPr>
-              <a:t>stands</a:t>
-            </a:r>
-            <a:r>
-              <a:rPr sz="1500" b="0">
-                <a:solidFill>
-                  <a:srgbClr val="3D3C38"/>
-                </a:solidFill>
-                <a:latin typeface="Calibri"/>
-              </a:rPr>
-              <a:t> and where it is </a:t>
-            </a:r>
-            <a:r>
-              <a:rPr sz="1500" b="1">
-                <a:solidFill>
-                  <a:srgbClr val="101010"/>
-                </a:solidFill>
-                <a:latin typeface="Calibri"/>
-              </a:rPr>
-              <a:t>heading</a:t>
-            </a:r>
-            <a:r>
-              <a:rPr sz="1500" b="0">
-                <a:solidFill>
-                  <a:srgbClr val="3D3C38"/>
-                </a:solidFill>
-                <a:latin typeface="Calibri"/>
-              </a:rPr>
-              <a:t>.</a:t>
-            </a:r>
-          </a:p>
-          <a:p>
-            <a:pPr algn="l">
-              <a:lnSpc>
-                <a:spcPct val="112000"/>
-              </a:lnSpc>
-              <a:spcAft>
-                <a:spcPts val="900"/>
-              </a:spcAft>
-            </a:pPr>
-            <a:r>
-              <a:rPr sz="1500" b="1">
-                <a:solidFill>
-                  <a:srgbClr val="C04A12"/>
-                </a:solidFill>
-                <a:latin typeface="Calibri"/>
-              </a:rPr>
-              <a:t>MPC +0.61   OXY +0.41   PSX +0.28</a:t>
-            </a:r>
-          </a:p>
-          <a:p>
-            <a:pPr algn="l">
-              <a:lnSpc>
-                <a:spcPct val="112000"/>
-              </a:lnSpc>
-              <a:spcAft>
-                <a:spcPts val="900"/>
-              </a:spcAft>
-            </a:pPr>
-            <a:r>
-              <a:rPr sz="1400" b="0">
-                <a:solidFill>
-                  <a:srgbClr val="6B6A63"/>
-                </a:solidFill>
-                <a:latin typeface="Calibri"/>
-              </a:rPr>
-              <a:t>Long the gap, short the structurally stuck, exit into eligibility.</a:t>
-            </a:r>
-          </a:p>
-        </p:txBody>
-      </p:sp>
-      <p:sp>
-        <p:nvSpPr>
-          <p:cNvPr id="9" name="Rectangle 8"/>
-          <p:cNvSpPr/>
-          <p:nvPr/>
-        </p:nvSpPr>
-        <p:spPr>
-          <a:xfrm>
-            <a:off x="777240" y="5623560"/>
-            <a:ext cx="10607040" cy="25400"/>
-          </a:xfrm>
-          <a:prstGeom prst="rect">
-            <a:avLst/>
-          </a:prstGeom>
-          <a:solidFill>
-            <a:srgbClr val="101010"/>
-          </a:solidFill>
-          <a:ln>
-            <a:noFill/>
-          </a:ln>
-          <a:effectLst/>
-        </p:spPr>
-        <p:style>
-          <a:lnRef idx="1">
-            <a:schemeClr val="accent1"/>
-          </a:lnRef>
-          <a:fillRef idx="3">
-            <a:schemeClr val="accent1"/>
-          </a:fillRef>
-          <a:effectRef idx="2">
-            <a:schemeClr val="accent1"/>
-          </a:effectRef>
-          <a:fontRef idx="minor">
-            <a:schemeClr val="lt1"/>
-          </a:fontRef>
-        </p:style>
-        <p:txBody>
-          <a:bodyPr rtlCol="0" anchor="ctr"/>
-          <a:lstStyle/>
-          <a:p>
-            <a:pPr algn="ctr"/>
-          </a:p>
-        </p:txBody>
-      </p:sp>
-      <p:sp>
-        <p:nvSpPr>
-          <p:cNvPr id="10" name="TextBox 9"/>
-          <p:cNvSpPr txBox="1"/>
-          <p:nvPr/>
-        </p:nvSpPr>
-        <p:spPr>
-          <a:xfrm>
-            <a:off x="777240" y="5852160"/>
-            <a:ext cx="10607040" cy="548640"/>
+            <a:off x="777240" y="5669280"/>
+            <a:ext cx="10607040" cy="731520"/>
           </a:xfrm>
           <a:prstGeom prst="rect">
             <a:avLst/>
@@ -6260,13 +6533,22 @@
               </a:spcAft>
             </a:pPr>
             <a:r>
-              <a:rPr sz="1900" b="1">
+              <a:rPr sz="2200" b="0">
                 <a:solidFill>
                   <a:srgbClr val="101010"/>
                 </a:solidFill>
                 <a:latin typeface="Calibri"/>
               </a:rPr>
-              <a:t>We deliver the ranking the brief asked for, and the honest error bar around it.</a:t>
+              <a:t>We give you the ranking the brief asked for, </a:t>
+            </a:r>
+            <a:r>
+              <a:rPr sz="2200" b="1">
+                <a:solidFill>
+                  <a:srgbClr val="C04A12"/>
+                </a:solidFill>
+                <a:latin typeface="Calibri"/>
+              </a:rPr>
+              <a:t>and the honest error bar around it.</a:t>
             </a:r>
           </a:p>
         </p:txBody>
@@ -6597,4 +6879,324 @@
   </a:objectDefaults>
   <a:extraClrSchemeLst/>
 </a:theme>
+</file>
+
+<file path=ppt/theme/theme2.xml><?xml version="1.0" encoding="utf-8"?>
+<a:theme xmlns:a="http://schemas.openxmlformats.org/drawingml/2006/main" name="Office Theme">
+  <a:themeElements>
+    <a:clrScheme name="Office">
+      <a:dk1>
+        <a:sysClr val="windowText" lastClr="000000"/>
+      </a:dk1>
+      <a:lt1>
+        <a:sysClr val="window" lastClr="FFFFFF"/>
+      </a:lt1>
+      <a:dk2>
+        <a:srgbClr val="1F497D"/>
+      </a:dk2>
+      <a:lt2>
+        <a:srgbClr val="EEECE1"/>
+      </a:lt2>
+      <a:accent1>
+        <a:srgbClr val="4F81BD"/>
+      </a:accent1>
+      <a:accent2>
+        <a:srgbClr val="C0504D"/>
+      </a:accent2>
+      <a:accent3>
+        <a:srgbClr val="9BBB59"/>
+      </a:accent3>
+      <a:accent4>
+        <a:srgbClr val="8064A2"/>
+      </a:accent4>
+      <a:accent5>
+        <a:srgbClr val="4BACC6"/>
+      </a:accent5>
+      <a:accent6>
+        <a:srgbClr val="F79646"/>
+      </a:accent6>
+      <a:hlink>
+        <a:srgbClr val="0000FF"/>
+      </a:hlink>
+      <a:folHlink>
+        <a:srgbClr val="800080"/>
+      </a:folHlink>
+    </a:clrScheme>
+    <a:fontScheme name="Office">
+      <a:majorFont>
+        <a:latin typeface="Calibri"/>
+        <a:ea typeface=""/>
+        <a:cs typeface=""/>
+        <a:font script="Jpan" typeface="ＭＳ Ｐゴシック"/>
+        <a:font script="Hang" typeface="맑은 고딕"/>
+        <a:font script="Hans" typeface="宋体"/>
+        <a:font script="Hant" typeface="新細明體"/>
+        <a:font script="Arab" typeface="Times New Roman"/>
+        <a:font script="Hebr" typeface="Times New Roman"/>
+        <a:font script="Thai" typeface="Angsana New"/>
+        <a:font script="Ethi" typeface="Nyala"/>
+        <a:font script="Beng" typeface="Vrinda"/>
+        <a:font script="Gujr" typeface="Shruti"/>
+        <a:font script="Khmr" typeface="MoolBoran"/>
+        <a:font script="Knda" typeface="Tunga"/>
+        <a:font script="Guru" typeface="Raavi"/>
+        <a:font script="Cans" typeface="Euphemia"/>
+        <a:font script="Cher" typeface="Plantagenet Cherokee"/>
+        <a:font script="Yiii" typeface="Microsoft Yi Baiti"/>
+        <a:font script="Tibt" typeface="Microsoft Himalaya"/>
+        <a:font script="Thaa" typeface="MV Boli"/>
+        <a:font script="Deva" typeface="Mangal"/>
+        <a:font script="Telu" typeface="Gautami"/>
+        <a:font script="Taml" typeface="Latha"/>
+        <a:font script="Syrc" typeface="Estrangelo Edessa"/>
+        <a:font script="Orya" typeface="Kalinga"/>
+        <a:font script="Mlym" typeface="Kartika"/>
+        <a:font script="Laoo" typeface="DokChampa"/>
+        <a:font script="Sinh" typeface="Iskoola Pota"/>
+        <a:font script="Mong" typeface="Mongolian Baiti"/>
+        <a:font script="Viet" typeface="Times New Roman"/>
+        <a:font script="Uigh" typeface="Microsoft Uighur"/>
+        <a:font script="Geor" typeface="Sylfaen"/>
+      </a:majorFont>
+      <a:minorFont>
+        <a:latin typeface="Calibri"/>
+        <a:ea typeface=""/>
+        <a:cs typeface=""/>
+        <a:font script="Jpan" typeface="ＭＳ Ｐゴシック"/>
+        <a:font script="Hang" typeface="맑은 고딕"/>
+        <a:font script="Hans" typeface="宋体"/>
+        <a:font script="Hant" typeface="新細明體"/>
+        <a:font script="Arab" typeface="Arial"/>
+        <a:font script="Hebr" typeface="Arial"/>
+        <a:font script="Thai" typeface="Cordia New"/>
+        <a:font script="Ethi" typeface="Nyala"/>
+        <a:font script="Beng" typeface="Vrinda"/>
+        <a:font script="Gujr" typeface="Shruti"/>
+        <a:font script="Khmr" typeface="DaunPenh"/>
+        <a:font script="Knda" typeface="Tunga"/>
+        <a:font script="Guru" typeface="Raavi"/>
+        <a:font script="Cans" typeface="Euphemia"/>
+        <a:font script="Cher" typeface="Plantagenet Cherokee"/>
+        <a:font script="Yiii" typeface="Microsoft Yi Baiti"/>
+        <a:font script="Tibt" typeface="Microsoft Himalaya"/>
+        <a:font script="Thaa" typeface="MV Boli"/>
+        <a:font script="Deva" typeface="Mangal"/>
+        <a:font script="Telu" typeface="Gautami"/>
+        <a:font script="Taml" typeface="Latha"/>
+        <a:font script="Syrc" typeface="Estrangelo Edessa"/>
+        <a:font script="Orya" typeface="Kalinga"/>
+        <a:font script="Mlym" typeface="Kartika"/>
+        <a:font script="Laoo" typeface="DokChampa"/>
+        <a:font script="Sinh" typeface="Iskoola Pota"/>
+        <a:font script="Mong" typeface="Mongolian Baiti"/>
+        <a:font script="Viet" typeface="Arial"/>
+        <a:font script="Uigh" typeface="Microsoft Uighur"/>
+        <a:font script="Geor" typeface="Sylfaen"/>
+      </a:minorFont>
+    </a:fontScheme>
+    <a:fmtScheme name="Office">
+      <a:fillStyleLst>
+        <a:solidFill>
+          <a:schemeClr val="phClr"/>
+        </a:solidFill>
+        <a:gradFill rotWithShape="1">
+          <a:gsLst>
+            <a:gs pos="0">
+              <a:schemeClr val="phClr">
+                <a:tint val="50000"/>
+                <a:satMod val="300000"/>
+              </a:schemeClr>
+            </a:gs>
+            <a:gs pos="35000">
+              <a:schemeClr val="phClr">
+                <a:tint val="37000"/>
+                <a:satMod val="300000"/>
+              </a:schemeClr>
+            </a:gs>
+            <a:gs pos="100000">
+              <a:schemeClr val="phClr">
+                <a:tint val="15000"/>
+                <a:satMod val="350000"/>
+              </a:schemeClr>
+            </a:gs>
+          </a:gsLst>
+          <a:lin ang="16200000" scaled="1"/>
+        </a:gradFill>
+        <a:gradFill rotWithShape="1">
+          <a:gsLst>
+            <a:gs pos="0">
+              <a:schemeClr val="phClr">
+                <a:tint val="100000"/>
+                <a:shade val="100000"/>
+                <a:satMod val="130000"/>
+              </a:schemeClr>
+            </a:gs>
+            <a:gs pos="100000">
+              <a:schemeClr val="phClr">
+                <a:tint val="50000"/>
+                <a:shade val="100000"/>
+                <a:satMod val="350000"/>
+              </a:schemeClr>
+            </a:gs>
+          </a:gsLst>
+          <a:lin ang="16200000" scaled="0"/>
+        </a:gradFill>
+      </a:fillStyleLst>
+      <a:lnStyleLst>
+        <a:ln w="9525" cap="flat" cmpd="sng" algn="ctr">
+          <a:solidFill>
+            <a:schemeClr val="phClr">
+              <a:shade val="95000"/>
+              <a:satMod val="105000"/>
+            </a:schemeClr>
+          </a:solidFill>
+          <a:prstDash val="solid"/>
+        </a:ln>
+        <a:ln w="25400" cap="flat" cmpd="sng" algn="ctr">
+          <a:solidFill>
+            <a:schemeClr val="phClr"/>
+          </a:solidFill>
+          <a:prstDash val="solid"/>
+        </a:ln>
+        <a:ln w="38100" cap="flat" cmpd="sng" algn="ctr">
+          <a:solidFill>
+            <a:schemeClr val="phClr"/>
+          </a:solidFill>
+          <a:prstDash val="solid"/>
+        </a:ln>
+      </a:lnStyleLst>
+      <a:effectStyleLst>
+        <a:effectStyle>
+          <a:effectLst>
+            <a:outerShdw blurRad="40000" dist="20000" dir="5400000" rotWithShape="0">
+              <a:srgbClr val="000000">
+                <a:alpha val="38000"/>
+              </a:srgbClr>
+            </a:outerShdw>
+          </a:effectLst>
+        </a:effectStyle>
+        <a:effectStyle>
+          <a:effectLst>
+            <a:outerShdw blurRad="40000" dist="23000" dir="5400000" rotWithShape="0">
+              <a:srgbClr val="000000">
+                <a:alpha val="35000"/>
+              </a:srgbClr>
+            </a:outerShdw>
+          </a:effectLst>
+        </a:effectStyle>
+        <a:effectStyle>
+          <a:effectLst>
+            <a:outerShdw blurRad="40000" dist="23000" dir="5400000" rotWithShape="0">
+              <a:srgbClr val="000000">
+                <a:alpha val="35000"/>
+              </a:srgbClr>
+            </a:outerShdw>
+          </a:effectLst>
+          <a:scene3d>
+            <a:camera prst="orthographicFront">
+              <a:rot lat="0" lon="0" rev="0"/>
+            </a:camera>
+            <a:lightRig rig="threePt" dir="t">
+              <a:rot lat="0" lon="0" rev="1200000"/>
+            </a:lightRig>
+          </a:scene3d>
+          <a:sp3d>
+            <a:bevelT w="63500" h="25400"/>
+          </a:sp3d>
+        </a:effectStyle>
+      </a:effectStyleLst>
+      <a:bgFillStyleLst>
+        <a:solidFill>
+          <a:schemeClr val="phClr"/>
+        </a:solidFill>
+        <a:gradFill rotWithShape="1">
+          <a:gsLst>
+            <a:gs pos="0">
+              <a:schemeClr val="phClr">
+                <a:tint val="40000"/>
+                <a:satMod val="350000"/>
+              </a:schemeClr>
+            </a:gs>
+            <a:gs pos="40000">
+              <a:schemeClr val="phClr">
+                <a:tint val="45000"/>
+                <a:shade val="99000"/>
+                <a:satMod val="350000"/>
+              </a:schemeClr>
+            </a:gs>
+            <a:gs pos="100000">
+              <a:schemeClr val="phClr">
+                <a:shade val="20000"/>
+                <a:satMod val="255000"/>
+              </a:schemeClr>
+            </a:gs>
+          </a:gsLst>
+          <a:path path="circle">
+            <a:fillToRect l="50000" t="-80000" r="50000" b="180000"/>
+          </a:path>
+        </a:gradFill>
+        <a:gradFill rotWithShape="1">
+          <a:gsLst>
+            <a:gs pos="0">
+              <a:schemeClr val="phClr">
+                <a:tint val="80000"/>
+                <a:satMod val="300000"/>
+              </a:schemeClr>
+            </a:gs>
+            <a:gs pos="100000">
+              <a:schemeClr val="phClr">
+                <a:shade val="30000"/>
+                <a:satMod val="200000"/>
+              </a:schemeClr>
+            </a:gs>
+          </a:gsLst>
+          <a:path path="circle">
+            <a:fillToRect l="50000" t="50000" r="50000" b="50000"/>
+          </a:path>
+        </a:gradFill>
+      </a:bgFillStyleLst>
+    </a:fmtScheme>
+  </a:themeElements>
+  <a:objectDefaults>
+    <a:spDef>
+      <a:spPr/>
+      <a:bodyPr/>
+      <a:lstStyle/>
+      <a:style>
+        <a:lnRef idx="1">
+          <a:schemeClr val="accent1"/>
+        </a:lnRef>
+        <a:fillRef idx="3">
+          <a:schemeClr val="accent1"/>
+        </a:fillRef>
+        <a:effectRef idx="2">
+          <a:schemeClr val="accent1"/>
+        </a:effectRef>
+        <a:fontRef idx="minor">
+          <a:schemeClr val="lt1"/>
+        </a:fontRef>
+      </a:style>
+    </a:spDef>
+    <a:lnDef>
+      <a:spPr/>
+      <a:bodyPr/>
+      <a:lstStyle/>
+      <a:style>
+        <a:lnRef idx="2">
+          <a:schemeClr val="accent1"/>
+        </a:lnRef>
+        <a:fillRef idx="0">
+          <a:schemeClr val="accent1"/>
+        </a:fillRef>
+        <a:effectRef idx="1">
+          <a:schemeClr val="accent1"/>
+        </a:effectRef>
+        <a:fontRef idx="minor">
+          <a:schemeClr val="tx1"/>
+        </a:fontRef>
+      </a:style>
+    </a:lnDef>
+  </a:objectDefaults>
+  <a:extraClrSchemeLst/>
+</a:theme>
 </file>
</xml_diff>

<commit_message>
Name the two grids specification curves rather than questions
The label was doing the wrong work. Simonsohn's criterion is that the
specifications inside one curve must test the same question, so calling level
and change "two questions" was accurate about why they are separated but put an
informal word where the technical one belongs.

They are now Specification curve A (level) and Specification curve B (change).
The word question survives only where it carries the argument: the two curves
are separated because they answer different questions, which is the
justification, not the name.

Co-Authored-By: Claude Opus 5 <noreply@anthropic.com>
</commit_message>
<xml_diff>
--- a/CONTESTED_pitch.pptx
+++ b/CONTESTED_pitch.pptx
@@ -685,7 +685,7 @@
           </a:p>
           <a:p>
             <a:r>
-              <a:t>publish different methods, every combination.</a:t>
+              <a:t>publish different specifications, every combination.</a:t>
             </a:r>
           </a:p>
           <a:p/>
@@ -5116,7 +5116,7 @@
                 </a:solidFill>
                 <a:latin typeface="Calibri"/>
               </a:rPr>
-              <a:t>All 18 companies, both questions.</a:t>
+              <a:t>All 18 companies, both specification curves.</a:t>
             </a:r>
           </a:p>
           <a:p>

</xml_diff>

<commit_message>
Word-for-word script for beats 2 and 3, with the demo verified click by click
Every number in the script was read off the running tool rather than the paper,
because a demo that does not do what the presenter just promised is worse than
no demo.

That check changed the choreography. The weight slider does not move the settled
counter at all: it stays at 2 while the table shuffles a little. Scripting it as
"watch it move" would have failed live. It is now scripted as "watch how little
happens", which is the six percent made visible and a better line.

It also found a stronger ending than planned. Holding the strict evidence bar
and flipping direction from level to change drops settled from 56 to 9 and
replaces the entire top three, BKR EXE SLB becoming CTRA OXY WMB. That single
click is the two-curve argument, so it is now the last thing the audience sees
before the bonus.

Verified sequence: 2 -> 33 -> 56 -> 9.

Co-Authored-By: Claude Opus 5 <noreply@anthropic.com>
</commit_message>
<xml_diff>
--- a/CONTESTED_pitch.pptx
+++ b/CONTESTED_pitch.pptx
@@ -882,88 +882,144 @@
           <a:lstStyle/>
           <a:p>
             <a:r>
-              <a:t>DEMO  |  68 sec  |  170 spoken words  |  DO EXACTLY THIS</a:t>
+              <a:t>DEMO  |  68 sec  |  FOUR CLICKS, NOTHING ELSE</a:t>
+            </a:r>
+          </a:p>
+          <a:p>
+            <a:r>
+              <a:t>Every number below is verified against the live tool.</a:t>
             </a:r>
           </a:p>
           <a:p/>
           <a:p>
             <a:r>
-              <a:t>1 (8s) "Eighteen companies ranked. Consensus here. This bar is how much of that</a:t>
-            </a:r>
-          </a:p>
-          <a:p>
-            <a:r>
-              <a:t>   rank is a choice."</a:t>
+              <a:t>0 (8s) POINT AT THE TABLE, do not click.</a:t>
+            </a:r>
+          </a:p>
+          <a:p>
+            <a:r>
+              <a:t>   "Eighteen companies ranked. Consensus here. This bar is how much of that</a:t>
+            </a:r>
+          </a:p>
+          <a:p>
+            <a:r>
+              <a:t>   rank is a choice, not a fact."</a:t>
             </a:r>
           </a:p>
           <a:p/>
           <a:p>
             <a:r>
-              <a:t>2 (15s) DRAG THE ENVIRONMENT SLIDER.</a:t>
-            </a:r>
-          </a:p>
-          <a:p>
-            <a:r>
-              <a:t>   "This is what every provider gives you. Pillar weights. It moves the median</a:t>
-            </a:r>
-          </a:p>
-          <a:p>
-            <a:r>
-              <a:t>   company three places. That is the six percent."</a:t>
+              <a:t>1 (15s) DRAG THE ENVIRONMENT SLIDER TO ~70%.</a:t>
+            </a:r>
+          </a:p>
+          <a:p>
+            <a:r>
+              <a:t>   "This is what every provider gives you. Pillar weights. Watch the settled</a:t>
+            </a:r>
+          </a:p>
+          <a:p>
+            <a:r>
+              <a:t>   counter. [pause] It does not move. Still two. That is the six percent, live."</a:t>
+            </a:r>
+          </a:p>
+          <a:p>
+            <a:r>
+              <a:t>   SCREEN: specs stay 17,496, settled stays 2. NOTHING BIG HAPPENS. That is the</a:t>
+            </a:r>
+          </a:p>
+          <a:p>
+            <a:r>
+              <a:t>   point. Do not promise a move here.</a:t>
             </a:r>
           </a:p>
           <a:p/>
           <a:p>
             <a:r>
-              <a:t>3 (20s) PIN Direction to LEVEL, then Evidence bar to STRICT.</a:t>
-            </a:r>
-          </a:p>
-          <a:p>
-            <a:r>
-              <a:t>   "Here is what nobody gives you. This is the question I am asking. And this is</a:t>
-            </a:r>
-          </a:p>
-          <a:p>
-            <a:r>
-              <a:t>   how demanding I am about evidence."</a:t>
+              <a:t>2 (18s) HIT RESET ALL. PIN Direction to LEVEL.</a:t>
+            </a:r>
+          </a:p>
+          <a:p>
+            <a:r>
+              <a:t>   "Now the part nobody gives you. This is the question itself. Cleanest today,</a:t>
+            </a:r>
+          </a:p>
+          <a:p>
+            <a:r>
+              <a:t>   or improving fastest? I pin it to today. Settled goes from two to</a:t>
+            </a:r>
+          </a:p>
+          <a:p>
+            <a:r>
+              <a:t>   thirty-three."</a:t>
+            </a:r>
+          </a:p>
+          <a:p>
+            <a:r>
+              <a:t>   SCREEN: 8,748 specs, settled 33, places 5.0</a:t>
             </a:r>
           </a:p>
           <a:p/>
           <a:p>
             <a:r>
-              <a:t>4 (15s) POINT AT THE SETTLED COUNTER.</a:t>
-            </a:r>
-          </a:p>
-          <a:p>
-            <a:r>
-              <a:t>   "Thirty-three of a hundred and fifty-three comparisons survive every method.</a:t>
-            </a:r>
-          </a:p>
-          <a:p>
-            <a:r>
-              <a:t>   Raise the bar, fifty-six. A league table asserts all hundred and fifty-three."</a:t>
+              <a:t>3 (15s) PIN Evidence bar to STRICT.</a:t>
+            </a:r>
+          </a:p>
+          <a:p>
+            <a:r>
+              <a:t>   "And this is how demanding I am about evidence. Thirty-three to fifty-six.</a:t>
+            </a:r>
+          </a:p>
+          <a:p>
+            <a:r>
+              <a:t>   A published league table asserts all hundred and fifty-three."</a:t>
+            </a:r>
+          </a:p>
+          <a:p>
+            <a:r>
+              <a:t>   SCREEN: 2,916 specs, settled 56, places 3.0</a:t>
             </a:r>
           </a:p>
           <a:p/>
           <a:p>
             <a:r>
-              <a:t>5 (10s) HOVER A POINT ON THE CURVE.</a:t>
-            </a:r>
-          </a:p>
-          <a:p>
-            <a:r>
-              <a:t>   "Every point tells you which nine choices produced it. No black box."</a:t>
+              <a:t>4 (12s) FLIP Direction to CHANGE.</a:t>
+            </a:r>
+          </a:p>
+          <a:p>
+            <a:r>
+              <a:t>   "Same data, same strictness, other question. Fifty-six collapses to nine.</a:t>
+            </a:r>
+          </a:p>
+          <a:p>
+            <a:r>
+              <a:t>   And look at the podium, three completely different companies. That is why we</a:t>
+            </a:r>
+          </a:p>
+          <a:p>
+            <a:r>
+              <a:t>   score the two curves separately."</a:t>
+            </a:r>
+          </a:p>
+          <a:p>
+            <a:r>
+              <a:t>   SCREEN: settled 9, places 6.0, top three flips BKR/EXE/SLB to CTRA/OXY/WMB</a:t>
             </a:r>
           </a:p>
           <a:p/>
           <a:p>
             <a:r>
-              <a:t>IF IT BREAKS: skip to the last slide, say "numbers are in the paper, tool is in</a:t>
-            </a:r>
-          </a:p>
-          <a:p>
-            <a:r>
-              <a:t>the repo". Never debug on stage.</a:t>
+              <a:t>HAND OVER: "Which brings us to the billion dollars."</a:t>
+            </a:r>
+          </a:p>
+          <a:p/>
+          <a:p>
+            <a:r>
+              <a:t>IF IT BREAKS: "The tool is in the repo and every number is in the paper."</a:t>
+            </a:r>
+          </a:p>
+          <a:p>
+            <a:r>
+              <a:t>Go straight to the bonus slide. Never debug on stage.</a:t>
             </a:r>
           </a:p>
         </p:txBody>

</xml_diff>